<commit_message>
Add mini ADM data-flows and risks-and-fixes slides for Friday
Covers the two gaps in the Friday presentation brief: a per-step
created/read/updated data-flow slide after the architecture map, and a
risk-to-fix slide after the engineering slide. Footers renumbered for
the 18-slide order and the traceability cross-reference updated.

Co-Authored-By: Claude Fable 5 <noreply@anthropic.com>
</commit_message>
<xml_diff>
--- a/pitch/ShopWell-Pitch.pptx
+++ b/pitch/ShopWell-Pitch.pptx
@@ -5,25 +5,27 @@
     <p:sldMasterId id="2147483650" r:id="rId1"/>
   </p:sldMasterIdLst>
   <p:notesMasterIdLst>
-    <p:notesMasterId r:id="rId6"/>
+    <p:notesMasterId r:id="rId18"/>
   </p:notesMasterIdLst>
   <p:sldIdLst>
-    <p:sldId id="256" r:id="rSld1"/>
-    <p:sldId id="257" r:id="rSld2"/>
-    <p:sldId id="258" r:id="rSld3"/>
-    <p:sldId id="259" r:id="rSld4"/>
-    <p:sldId id="260" r:id="rSld5"/>
-    <p:sldId id="261" r:id="rSld6"/>
-    <p:sldId id="262" r:id="rSld7"/>
-    <p:sldId id="263" r:id="rSld8"/>
-    <p:sldId id="264" r:id="rSld9"/>
-    <p:sldId id="265" r:id="rSld10"/>
-    <p:sldId id="266" r:id="rSld11"/>
-    <p:sldId id="267" r:id="rSld12"/>
-    <p:sldId id="268" r:id="rSld13"/>
-    <p:sldId id="269" r:id="rSld14"/>
-    <p:sldId id="270" r:id="rSld15"/>
-    <p:sldId id="271" r:id="rSld16"/>
+    <p:sldId id="256" r:id="rId2"/>
+    <p:sldId id="257" r:id="rId3"/>
+    <p:sldId id="258" r:id="rId4"/>
+    <p:sldId id="259" r:id="rId5"/>
+    <p:sldId id="260" r:id="rId6"/>
+    <p:sldId id="261" r:id="rId7"/>
+    <p:sldId id="262" r:id="rId8"/>
+    <p:sldId id="263" r:id="rId9"/>
+    <p:sldId id="272" r:id="rId25"/>
+    <p:sldId id="264" r:id="rId10"/>
+    <p:sldId id="265" r:id="rId11"/>
+    <p:sldId id="266" r:id="rId12"/>
+    <p:sldId id="267" r:id="rId13"/>
+    <p:sldId id="273" r:id="rId26"/>
+    <p:sldId id="268" r:id="rId14"/>
+    <p:sldId id="269" r:id="rId15"/>
+    <p:sldId id="270" r:id="rId16"/>
+    <p:sldId id="271" r:id="rId17"/>
   </p:sldIdLst>
   <p:sldSz cx="9144000" cy="5143500" type="screen16x9"/>
   <p:notesSz cx="5143500" cy="9144000"/>
@@ -124,13 +126,28 @@
       <p14:sectionLst xmlns:p14="http://schemas.microsoft.com/office/powerpoint/2010/main">
         <p14:section name="2026 Project" id="{C4A669F0-B9A2-C64D-9FD0-603AC247FCC7}">
           <p14:sldIdLst>
-            <p14:sldId id="2147483628"/>
-            <p14:sldId id="2147483629"/>
-            <p14:sldId id="2147483636"/>
-            <p14:sldId id="292"/>
+            <p14:sldId id="256"/>
+            <p14:sldId id="257"/>
+            <p14:sldId id="258"/>
+            <p14:sldId id="259"/>
+            <p14:sldId id="260"/>
+            <p14:sldId id="261"/>
+            <p14:sldId id="262"/>
+            <p14:sldId id="263"/>
+            <p14:sldId id="264"/>
+            <p14:sldId id="265"/>
+            <p14:sldId id="266"/>
+            <p14:sldId id="267"/>
+            <p14:sldId id="268"/>
+            <p14:sldId id="269"/>
+            <p14:sldId id="270"/>
+            <p14:sldId id="271"/>
           </p14:sldIdLst>
         </p14:section>
       </p14:sectionLst>
+    </p:ext>
+    <p:ext uri="{EFAFB233-063F-42B5-8137-9DF3F51BA10A}">
+      <p15:sldGuideLst xmlns:p15="http://schemas.microsoft.com/office/powerpoint/2012/main"/>
     </p:ext>
   </p:extLst>
 </p:presentation>
@@ -158,7 +175,7 @@
         <pc:chgData name="Sabrina Poll" userId="e37d4011-9ea3-4deb-a0ee-0510b64e7187" providerId="ADAL" clId="{2BA24524-4C28-4AF2-914F-E5BE22FFE1FD}" dt="2026-07-06T15:43:40.660" v="76" actId="18676"/>
         <pc:sldMkLst>
           <pc:docMk/>
-          <pc:sldMk cId="0" sldId="256"/>
+          <pc:sldMk cId="804193802" sldId="256"/>
         </pc:sldMkLst>
       </pc:sldChg>
       <pc:sldChg chg="del">
@@ -720,7 +737,7 @@
           </a:lstStyle>
           <a:p>
             <a:fld id="{A8428D72-9849-43D5-88AF-6D90E41C0E33}" type="datetimeFigureOut">
-              <a:t>7/6/2026</a:t>
+              <a:t>7/9/26</a:t>
             </a:fld>
             <a:endParaRPr lang="en-GB"/>
           </a:p>
@@ -6579,7 +6596,7 @@
           <a:p>
             <a:r>
               <a:rPr lang="en-GB" dirty="0"/>
-              <a:t>The organic produce marketplace — every local farm, one basket, one payment.  ·  Client pitch, July 2026</a:t>
+              <a:t>The organic produce marketplace for every local farm, one basket, one payment.</a:t>
             </a:r>
           </a:p>
         </p:txBody>
@@ -6688,7 +6705,7 @@
 </file>
 
 <file path=ppt/slides/slide10.xml><?xml version="1.0" encoding="utf-8"?>
-<p:sld xmlns:a="http://schemas.openxmlformats.org/drawingml/2006/main" xmlns:p="http://schemas.openxmlformats.org/presentationml/2006/main" xmlns:r="http://schemas.openxmlformats.org/officeDocument/2006/relationships">
+<p:sld xmlns:a="http://schemas.openxmlformats.org/drawingml/2006/main" xmlns:r="http://schemas.openxmlformats.org/officeDocument/2006/relationships" xmlns:p="http://schemas.openxmlformats.org/presentationml/2006/main">
   <p:cSld>
     <p:spTree>
       <p:nvGrpSpPr>
@@ -6696,7 +6713,14 @@
         <p:cNvGrpSpPr/>
         <p:nvPr/>
       </p:nvGrpSpPr>
-      <p:grpSpPr/>
+      <p:grpSpPr>
+        <a:xfrm>
+          <a:off x="0" y="0"/>
+          <a:ext cx="0" cy="0"/>
+          <a:chOff x="0" y="0"/>
+          <a:chExt cx="0" cy="0"/>
+        </a:xfrm>
+      </p:grpSpPr>
       <p:sp>
         <p:nvSpPr>
           <p:cNvPr id="2" name="Rectangle 1"/>
@@ -6738,6 +6762,7 @@
           <a:lstStyle/>
           <a:p>
             <a:pPr algn="ctr"/>
+            <a:endParaRPr/>
           </a:p>
         </p:txBody>
       </p:sp>
@@ -6758,7 +6783,7 @@
           <a:noFill/>
         </p:spPr>
         <p:txBody>
-          <a:bodyPr wrap="square" anchor="t" lIns="0" rIns="0" tIns="0" bIns="0">
+          <a:bodyPr wrap="square" lIns="0" tIns="0" rIns="0" bIns="0" anchor="t">
             <a:spAutoFit/>
           </a:bodyPr>
           <a:lstStyle/>
@@ -6862,7 +6887,7 @@
           </a:fontRef>
         </p:style>
         <p:txBody>
-          <a:bodyPr rtlCol="0" anchor="t" wrap="square" lIns="96012" rIns="82296" tIns="96012" bIns="41148"/>
+          <a:bodyPr wrap="square" lIns="96012" tIns="96012" rIns="82296" bIns="41148" rtlCol="0" anchor="t"/>
           <a:lstStyle/>
           <a:p>
             <a:pPr algn="l">
@@ -6942,6 +6967,7 @@
           <a:lstStyle/>
           <a:p>
             <a:pPr algn="ctr"/>
+            <a:endParaRPr/>
           </a:p>
         </p:txBody>
       </p:sp>
@@ -6986,7 +7012,7 @@
           </a:fontRef>
         </p:style>
         <p:txBody>
-          <a:bodyPr rtlCol="0" anchor="t" wrap="square" lIns="96012" rIns="82296" tIns="96012" bIns="41148"/>
+          <a:bodyPr wrap="square" lIns="96012" tIns="96012" rIns="82296" bIns="41148" rtlCol="0" anchor="t"/>
           <a:lstStyle/>
           <a:p>
             <a:pPr algn="l">
@@ -7066,6 +7092,7 @@
           <a:lstStyle/>
           <a:p>
             <a:pPr algn="ctr"/>
+            <a:endParaRPr/>
           </a:p>
         </p:txBody>
       </p:sp>
@@ -7110,7 +7137,7 @@
           </a:fontRef>
         </p:style>
         <p:txBody>
-          <a:bodyPr rtlCol="0" anchor="t" wrap="square" lIns="96012" rIns="82296" tIns="96012" bIns="41148"/>
+          <a:bodyPr wrap="square" lIns="96012" tIns="96012" rIns="82296" bIns="41148" rtlCol="0" anchor="t"/>
           <a:lstStyle/>
           <a:p>
             <a:pPr algn="l">
@@ -7190,6 +7217,7 @@
           <a:lstStyle/>
           <a:p>
             <a:pPr algn="ctr"/>
+            <a:endParaRPr/>
           </a:p>
         </p:txBody>
       </p:sp>
@@ -7234,7 +7262,7 @@
           </a:fontRef>
         </p:style>
         <p:txBody>
-          <a:bodyPr rtlCol="0" anchor="t" wrap="square" lIns="96012" rIns="82296" tIns="96012" bIns="41148"/>
+          <a:bodyPr wrap="square" lIns="96012" tIns="96012" rIns="82296" bIns="41148" rtlCol="0" anchor="t"/>
           <a:lstStyle/>
           <a:p>
             <a:pPr algn="l">
@@ -7314,6 +7342,7 @@
           <a:lstStyle/>
           <a:p>
             <a:pPr algn="ctr"/>
+            <a:endParaRPr/>
           </a:p>
         </p:txBody>
       </p:sp>
@@ -7358,7 +7387,7 @@
           </a:fontRef>
         </p:style>
         <p:txBody>
-          <a:bodyPr rtlCol="0" anchor="t" wrap="square" lIns="96012" rIns="82296" tIns="96012" bIns="41148"/>
+          <a:bodyPr wrap="square" lIns="96012" tIns="96012" rIns="82296" bIns="41148" rtlCol="0" anchor="t"/>
           <a:lstStyle/>
           <a:p>
             <a:pPr algn="l">
@@ -7438,6 +7467,7 @@
           <a:lstStyle/>
           <a:p>
             <a:pPr algn="ctr"/>
+            <a:endParaRPr/>
           </a:p>
         </p:txBody>
       </p:sp>
@@ -7482,7 +7512,7 @@
           </a:fontRef>
         </p:style>
         <p:txBody>
-          <a:bodyPr rtlCol="0" anchor="t" wrap="square" lIns="96012" rIns="82296" tIns="96012" bIns="41148"/>
+          <a:bodyPr wrap="square" lIns="96012" tIns="96012" rIns="82296" bIns="41148" rtlCol="0" anchor="t"/>
           <a:lstStyle/>
           <a:p>
             <a:pPr algn="l">
@@ -7562,6 +7592,7 @@
           <a:lstStyle/>
           <a:p>
             <a:pPr algn="ctr"/>
+            <a:endParaRPr/>
           </a:p>
         </p:txBody>
       </p:sp>
@@ -7594,7 +7625,7 @@
                 </a:solidFill>
                 <a:latin typeface="Arial"/>
               </a:rPr>
-              <a:t>Shop Well — client pitch  ·  10</a:t>
+              <a:t>Shop Well — client pitch  ·  11</a:t>
             </a:r>
           </a:p>
         </p:txBody>
@@ -7608,7 +7639,7 @@
 </file>
 
 <file path=ppt/slides/slide11.xml><?xml version="1.0" encoding="utf-8"?>
-<p:sld xmlns:a="http://schemas.openxmlformats.org/drawingml/2006/main" xmlns:p="http://schemas.openxmlformats.org/presentationml/2006/main" xmlns:r="http://schemas.openxmlformats.org/officeDocument/2006/relationships">
+<p:sld xmlns:a="http://schemas.openxmlformats.org/drawingml/2006/main" xmlns:r="http://schemas.openxmlformats.org/officeDocument/2006/relationships" xmlns:p="http://schemas.openxmlformats.org/presentationml/2006/main">
   <p:cSld>
     <p:spTree>
       <p:nvGrpSpPr>
@@ -7616,7 +7647,14 @@
         <p:cNvGrpSpPr/>
         <p:nvPr/>
       </p:nvGrpSpPr>
-      <p:grpSpPr/>
+      <p:grpSpPr>
+        <a:xfrm>
+          <a:off x="0" y="0"/>
+          <a:ext cx="0" cy="0"/>
+          <a:chOff x="0" y="0"/>
+          <a:chExt cx="0" cy="0"/>
+        </a:xfrm>
+      </p:grpSpPr>
       <p:sp>
         <p:nvSpPr>
           <p:cNvPr id="2" name="Rectangle 1"/>
@@ -7658,6 +7696,7 @@
           <a:lstStyle/>
           <a:p>
             <a:pPr algn="ctr"/>
+            <a:endParaRPr/>
           </a:p>
         </p:txBody>
       </p:sp>
@@ -7678,7 +7717,7 @@
           <a:noFill/>
         </p:spPr>
         <p:txBody>
-          <a:bodyPr wrap="square" anchor="t" lIns="0" rIns="0" tIns="0" bIns="0">
+          <a:bodyPr wrap="square" lIns="0" tIns="0" rIns="0" bIns="0" anchor="t">
             <a:spAutoFit/>
           </a:bodyPr>
           <a:lstStyle/>
@@ -7782,6 +7821,7 @@
           <a:lstStyle/>
           <a:p>
             <a:pPr algn="ctr"/>
+            <a:endParaRPr/>
           </a:p>
         </p:txBody>
       </p:sp>
@@ -7838,7 +7878,7 @@
           <a:noFill/>
         </p:spPr>
         <p:txBody>
-          <a:bodyPr wrap="square" anchor="t" lIns="0" rIns="0" tIns="0" bIns="0">
+          <a:bodyPr wrap="square" lIns="0" tIns="0" rIns="0" bIns="0" anchor="t">
             <a:spAutoFit/>
           </a:bodyPr>
           <a:lstStyle/>
@@ -7913,6 +7953,7 @@
           <a:lstStyle/>
           <a:p>
             <a:pPr algn="ctr"/>
+            <a:endParaRPr/>
           </a:p>
         </p:txBody>
       </p:sp>
@@ -7969,7 +8010,7 @@
           <a:noFill/>
         </p:spPr>
         <p:txBody>
-          <a:bodyPr wrap="square" anchor="t" lIns="0" rIns="0" tIns="0" bIns="0">
+          <a:bodyPr wrap="square" lIns="0" tIns="0" rIns="0" bIns="0" anchor="t">
             <a:spAutoFit/>
           </a:bodyPr>
           <a:lstStyle/>
@@ -8044,6 +8085,7 @@
           <a:lstStyle/>
           <a:p>
             <a:pPr algn="ctr"/>
+            <a:endParaRPr/>
           </a:p>
         </p:txBody>
       </p:sp>
@@ -8100,7 +8142,7 @@
           <a:noFill/>
         </p:spPr>
         <p:txBody>
-          <a:bodyPr wrap="square" anchor="t" lIns="0" rIns="0" tIns="0" bIns="0">
+          <a:bodyPr wrap="square" lIns="0" tIns="0" rIns="0" bIns="0" anchor="t">
             <a:spAutoFit/>
           </a:bodyPr>
           <a:lstStyle/>
@@ -8175,6 +8217,7 @@
           <a:lstStyle/>
           <a:p>
             <a:pPr algn="ctr"/>
+            <a:endParaRPr/>
           </a:p>
         </p:txBody>
       </p:sp>
@@ -8231,7 +8274,7 @@
           <a:noFill/>
         </p:spPr>
         <p:txBody>
-          <a:bodyPr wrap="square" anchor="t" lIns="0" rIns="0" tIns="0" bIns="0">
+          <a:bodyPr wrap="square" lIns="0" tIns="0" rIns="0" bIns="0" anchor="t">
             <a:spAutoFit/>
           </a:bodyPr>
           <a:lstStyle/>
@@ -8306,6 +8349,7 @@
           <a:lstStyle/>
           <a:p>
             <a:pPr algn="ctr"/>
+            <a:endParaRPr/>
           </a:p>
         </p:txBody>
       </p:sp>
@@ -8326,7 +8370,7 @@
           <a:noFill/>
         </p:spPr>
         <p:txBody>
-          <a:bodyPr wrap="square" anchor="t" lIns="0" rIns="0" tIns="0" bIns="0">
+          <a:bodyPr wrap="square" lIns="0" tIns="0" rIns="0" bIns="0" anchor="t">
             <a:spAutoFit/>
           </a:bodyPr>
           <a:lstStyle/>
@@ -8399,7 +8443,7 @@
           </a:fontRef>
         </p:style>
         <p:txBody>
-          <a:bodyPr rtlCol="0" anchor="t" wrap="square" lIns="150876" rIns="123444" tIns="137160"/>
+          <a:bodyPr wrap="square" lIns="150876" tIns="137160" rIns="123444" rtlCol="0" anchor="t"/>
           <a:lstStyle/>
           <a:p>
             <a:pPr algn="l">
@@ -8624,7 +8668,7 @@
                 </a:solidFill>
                 <a:latin typeface="Arial"/>
               </a:rPr>
-              <a:t>Shop Well — client pitch  ·  11</a:t>
+              <a:t>Shop Well — client pitch  ·  12</a:t>
             </a:r>
           </a:p>
         </p:txBody>
@@ -8638,7 +8682,7 @@
 </file>
 
 <file path=ppt/slides/slide12.xml><?xml version="1.0" encoding="utf-8"?>
-<p:sld xmlns:a="http://schemas.openxmlformats.org/drawingml/2006/main" xmlns:p="http://schemas.openxmlformats.org/presentationml/2006/main" xmlns:r="http://schemas.openxmlformats.org/officeDocument/2006/relationships">
+<p:sld xmlns:a="http://schemas.openxmlformats.org/drawingml/2006/main" xmlns:r="http://schemas.openxmlformats.org/officeDocument/2006/relationships" xmlns:p="http://schemas.openxmlformats.org/presentationml/2006/main">
   <p:cSld>
     <p:spTree>
       <p:nvGrpSpPr>
@@ -8646,7 +8690,14 @@
         <p:cNvGrpSpPr/>
         <p:nvPr/>
       </p:nvGrpSpPr>
-      <p:grpSpPr/>
+      <p:grpSpPr>
+        <a:xfrm>
+          <a:off x="0" y="0"/>
+          <a:ext cx="0" cy="0"/>
+          <a:chOff x="0" y="0"/>
+          <a:chExt cx="0" cy="0"/>
+        </a:xfrm>
+      </p:grpSpPr>
       <p:sp>
         <p:nvSpPr>
           <p:cNvPr id="2" name="Rectangle 1"/>
@@ -8688,6 +8739,7 @@
           <a:lstStyle/>
           <a:p>
             <a:pPr algn="ctr"/>
+            <a:endParaRPr/>
           </a:p>
         </p:txBody>
       </p:sp>
@@ -8708,7 +8760,7 @@
           <a:noFill/>
         </p:spPr>
         <p:txBody>
-          <a:bodyPr wrap="square" anchor="t" lIns="0" rIns="0" tIns="0" bIns="0">
+          <a:bodyPr wrap="square" lIns="0" tIns="0" rIns="0" bIns="0" anchor="t">
             <a:spAutoFit/>
           </a:bodyPr>
           <a:lstStyle/>
@@ -8793,7 +8845,7 @@
           </a:fontRef>
         </p:style>
         <p:txBody>
-          <a:bodyPr rtlCol="0" anchor="t" wrap="square" lIns="96012" rIns="82296" tIns="96012" bIns="41148"/>
+          <a:bodyPr wrap="square" lIns="96012" tIns="96012" rIns="82296" bIns="41148" rtlCol="0" anchor="t"/>
           <a:lstStyle/>
           <a:p>
             <a:pPr algn="l">
@@ -8873,6 +8925,7 @@
           <a:lstStyle/>
           <a:p>
             <a:pPr algn="ctr"/>
+            <a:endParaRPr/>
           </a:p>
         </p:txBody>
       </p:sp>
@@ -8917,7 +8970,7 @@
           </a:fontRef>
         </p:style>
         <p:txBody>
-          <a:bodyPr rtlCol="0" anchor="t" wrap="square" lIns="96012" rIns="82296" tIns="96012" bIns="41148"/>
+          <a:bodyPr wrap="square" lIns="96012" tIns="96012" rIns="82296" bIns="41148" rtlCol="0" anchor="t"/>
           <a:lstStyle/>
           <a:p>
             <a:pPr algn="l">
@@ -8997,6 +9050,7 @@
           <a:lstStyle/>
           <a:p>
             <a:pPr algn="ctr"/>
+            <a:endParaRPr/>
           </a:p>
         </p:txBody>
       </p:sp>
@@ -9041,7 +9095,7 @@
           </a:fontRef>
         </p:style>
         <p:txBody>
-          <a:bodyPr rtlCol="0" anchor="t" wrap="square" lIns="96012" rIns="82296" tIns="96012" bIns="41148"/>
+          <a:bodyPr wrap="square" lIns="96012" tIns="96012" rIns="82296" bIns="41148" rtlCol="0" anchor="t"/>
           <a:lstStyle/>
           <a:p>
             <a:pPr algn="l">
@@ -9121,6 +9175,7 @@
           <a:lstStyle/>
           <a:p>
             <a:pPr algn="ctr"/>
+            <a:endParaRPr/>
           </a:p>
         </p:txBody>
       </p:sp>
@@ -9165,7 +9220,7 @@
           </a:fontRef>
         </p:style>
         <p:txBody>
-          <a:bodyPr rtlCol="0" anchor="t" wrap="square" lIns="96012" rIns="82296" tIns="96012" bIns="41148"/>
+          <a:bodyPr wrap="square" lIns="96012" tIns="96012" rIns="82296" bIns="41148" rtlCol="0" anchor="t"/>
           <a:lstStyle/>
           <a:p>
             <a:pPr algn="l">
@@ -9245,6 +9300,7 @@
           <a:lstStyle/>
           <a:p>
             <a:pPr algn="ctr"/>
+            <a:endParaRPr/>
           </a:p>
         </p:txBody>
       </p:sp>
@@ -9289,7 +9345,7 @@
           </a:fontRef>
         </p:style>
         <p:txBody>
-          <a:bodyPr rtlCol="0" anchor="t" wrap="square" lIns="96012" rIns="82296" tIns="96012" bIns="41148"/>
+          <a:bodyPr wrap="square" lIns="96012" tIns="96012" rIns="82296" bIns="41148" rtlCol="0" anchor="t"/>
           <a:lstStyle/>
           <a:p>
             <a:pPr algn="l">
@@ -9369,6 +9425,7 @@
           <a:lstStyle/>
           <a:p>
             <a:pPr algn="ctr"/>
+            <a:endParaRPr/>
           </a:p>
         </p:txBody>
       </p:sp>
@@ -9413,7 +9470,7 @@
           </a:fontRef>
         </p:style>
         <p:txBody>
-          <a:bodyPr rtlCol="0" anchor="t" wrap="square" lIns="96012" rIns="82296" tIns="96012" bIns="41148"/>
+          <a:bodyPr wrap="square" lIns="96012" tIns="96012" rIns="82296" bIns="41148" rtlCol="0" anchor="t"/>
           <a:lstStyle/>
           <a:p>
             <a:pPr algn="l">
@@ -9493,6 +9550,7 @@
           <a:lstStyle/>
           <a:p>
             <a:pPr algn="ctr"/>
+            <a:endParaRPr/>
           </a:p>
         </p:txBody>
       </p:sp>
@@ -9525,7 +9583,7 @@
                 </a:solidFill>
                 <a:latin typeface="Arial"/>
               </a:rPr>
-              <a:t>Shop Well — client pitch  ·  12</a:t>
+              <a:t>Shop Well — client pitch  ·  13</a:t>
             </a:r>
           </a:p>
         </p:txBody>
@@ -9539,7 +9597,7 @@
 </file>
 
 <file path=ppt/slides/slide13.xml><?xml version="1.0" encoding="utf-8"?>
-<p:sld xmlns:a="http://schemas.openxmlformats.org/drawingml/2006/main" xmlns:p="http://schemas.openxmlformats.org/presentationml/2006/main" xmlns:r="http://schemas.openxmlformats.org/officeDocument/2006/relationships">
+<p:sld xmlns:a="http://schemas.openxmlformats.org/drawingml/2006/main" xmlns:r="http://schemas.openxmlformats.org/officeDocument/2006/relationships" xmlns:p="http://schemas.openxmlformats.org/presentationml/2006/main">
   <p:cSld>
     <p:spTree>
       <p:nvGrpSpPr>
@@ -9547,7 +9605,14 @@
         <p:cNvGrpSpPr/>
         <p:nvPr/>
       </p:nvGrpSpPr>
-      <p:grpSpPr/>
+      <p:grpSpPr>
+        <a:xfrm>
+          <a:off x="0" y="0"/>
+          <a:ext cx="0" cy="0"/>
+          <a:chOff x="0" y="0"/>
+          <a:chExt cx="0" cy="0"/>
+        </a:xfrm>
+      </p:grpSpPr>
       <p:sp>
         <p:nvSpPr>
           <p:cNvPr id="2" name="Rectangle 1"/>
@@ -9589,6 +9654,7 @@
           <a:lstStyle/>
           <a:p>
             <a:pPr algn="ctr"/>
+            <a:endParaRPr/>
           </a:p>
         </p:txBody>
       </p:sp>
@@ -9609,7 +9675,7 @@
           <a:noFill/>
         </p:spPr>
         <p:txBody>
-          <a:bodyPr wrap="square" anchor="t" lIns="0" rIns="0" tIns="0" bIns="0">
+          <a:bodyPr wrap="square" lIns="0" tIns="0" rIns="0" bIns="0" anchor="t">
             <a:spAutoFit/>
           </a:bodyPr>
           <a:lstStyle/>
@@ -10253,7 +10319,7 @@
           </a:fontRef>
         </p:style>
         <p:txBody>
-          <a:bodyPr rtlCol="0" anchor="ctr" wrap="square" lIns="82296" rIns="82296" tIns="0" bIns="0"/>
+          <a:bodyPr wrap="square" lIns="82296" tIns="0" rIns="82296" bIns="0" rtlCol="0" anchor="ctr"/>
           <a:lstStyle/>
           <a:p>
             <a:pPr algn="ctr"/>
@@ -10264,7 +10330,7 @@
                 </a:solidFill>
                 <a:latin typeface="Arial"/>
               </a:rPr>
-              <a:t>Non-functional requirements (security, stock integrity, accessibility, mobile) — see slide 10.</a:t>
+              <a:t>Non-functional requirements (security, stock integrity, accessibility, mobile) — see slide 11.</a:t>
             </a:r>
           </a:p>
         </p:txBody>
@@ -10298,7 +10364,7 @@
                 </a:solidFill>
                 <a:latin typeface="Arial"/>
               </a:rPr>
-              <a:t>Shop Well — client pitch  ·  13</a:t>
+              <a:t>Shop Well — client pitch  ·  15</a:t>
             </a:r>
           </a:p>
         </p:txBody>
@@ -10312,7 +10378,7 @@
 </file>
 
 <file path=ppt/slides/slide14.xml><?xml version="1.0" encoding="utf-8"?>
-<p:sld xmlns:a="http://schemas.openxmlformats.org/drawingml/2006/main" xmlns:p="http://schemas.openxmlformats.org/presentationml/2006/main" xmlns:r="http://schemas.openxmlformats.org/officeDocument/2006/relationships">
+<p:sld xmlns:a="http://schemas.openxmlformats.org/drawingml/2006/main" xmlns:r="http://schemas.openxmlformats.org/officeDocument/2006/relationships" xmlns:p="http://schemas.openxmlformats.org/presentationml/2006/main">
   <p:cSld>
     <p:spTree>
       <p:nvGrpSpPr>
@@ -10320,7 +10386,14 @@
         <p:cNvGrpSpPr/>
         <p:nvPr/>
       </p:nvGrpSpPr>
-      <p:grpSpPr/>
+      <p:grpSpPr>
+        <a:xfrm>
+          <a:off x="0" y="0"/>
+          <a:ext cx="0" cy="0"/>
+          <a:chOff x="0" y="0"/>
+          <a:chExt cx="0" cy="0"/>
+        </a:xfrm>
+      </p:grpSpPr>
       <p:sp>
         <p:nvSpPr>
           <p:cNvPr id="2" name="Rectangle 1"/>
@@ -10362,6 +10435,7 @@
           <a:lstStyle/>
           <a:p>
             <a:pPr algn="ctr"/>
+            <a:endParaRPr/>
           </a:p>
         </p:txBody>
       </p:sp>
@@ -10382,7 +10456,7 @@
           <a:noFill/>
         </p:spPr>
         <p:txBody>
-          <a:bodyPr wrap="square" anchor="t" lIns="0" rIns="0" tIns="0" bIns="0">
+          <a:bodyPr wrap="square" lIns="0" tIns="0" rIns="0" bIns="0" anchor="t">
             <a:spAutoFit/>
           </a:bodyPr>
           <a:lstStyle/>
@@ -10465,7 +10539,7 @@
           </a:fontRef>
         </p:style>
         <p:txBody>
-          <a:bodyPr rtlCol="0" anchor="ctr" wrap="square" lIns="82296" rIns="82296" tIns="0" bIns="0"/>
+          <a:bodyPr wrap="square" lIns="82296" tIns="0" rIns="82296" bIns="0" rtlCol="0" anchor="ctr"/>
           <a:lstStyle/>
           <a:p>
             <a:pPr algn="ctr"/>
@@ -10522,7 +10596,7 @@
           </a:fontRef>
         </p:style>
         <p:txBody>
-          <a:bodyPr rtlCol="0" anchor="t" wrap="square" lIns="96012" rIns="82296" tIns="109728" bIns="41148"/>
+          <a:bodyPr wrap="square" lIns="96012" tIns="109728" rIns="82296" bIns="41148" rtlCol="0" anchor="t"/>
           <a:lstStyle/>
           <a:p>
             <a:pPr algn="l">
@@ -10637,7 +10711,7 @@
           </a:fontRef>
         </p:style>
         <p:txBody>
-          <a:bodyPr rtlCol="0" anchor="ctr" wrap="square" lIns="82296" rIns="82296" tIns="0" bIns="0"/>
+          <a:bodyPr wrap="square" lIns="82296" tIns="0" rIns="82296" bIns="0" rtlCol="0" anchor="ctr"/>
           <a:lstStyle/>
           <a:p>
             <a:pPr algn="ctr"/>
@@ -10694,7 +10768,7 @@
           </a:fontRef>
         </p:style>
         <p:txBody>
-          <a:bodyPr rtlCol="0" anchor="t" wrap="square" lIns="96012" rIns="82296" tIns="109728" bIns="41148"/>
+          <a:bodyPr wrap="square" lIns="96012" tIns="109728" rIns="82296" bIns="41148" rtlCol="0" anchor="t"/>
           <a:lstStyle/>
           <a:p>
             <a:pPr algn="l">
@@ -10809,7 +10883,7 @@
           </a:fontRef>
         </p:style>
         <p:txBody>
-          <a:bodyPr rtlCol="0" anchor="ctr" wrap="square" lIns="82296" rIns="82296" tIns="0" bIns="0"/>
+          <a:bodyPr wrap="square" lIns="82296" tIns="0" rIns="82296" bIns="0" rtlCol="0" anchor="ctr"/>
           <a:lstStyle/>
           <a:p>
             <a:pPr algn="ctr"/>
@@ -10866,7 +10940,7 @@
           </a:fontRef>
         </p:style>
         <p:txBody>
-          <a:bodyPr rtlCol="0" anchor="t" wrap="square" lIns="96012" rIns="82296" tIns="109728" bIns="41148"/>
+          <a:bodyPr wrap="square" lIns="96012" tIns="109728" rIns="82296" bIns="41148" rtlCol="0" anchor="t"/>
           <a:lstStyle/>
           <a:p>
             <a:pPr algn="l">
@@ -10981,7 +11055,7 @@
           </a:fontRef>
         </p:style>
         <p:txBody>
-          <a:bodyPr rtlCol="0" anchor="ctr" wrap="square" lIns="82296" rIns="82296" tIns="0" bIns="0"/>
+          <a:bodyPr wrap="square" lIns="82296" tIns="0" rIns="82296" bIns="0" rtlCol="0" anchor="ctr"/>
           <a:lstStyle/>
           <a:p>
             <a:pPr algn="ctr"/>
@@ -11038,7 +11112,7 @@
           </a:fontRef>
         </p:style>
         <p:txBody>
-          <a:bodyPr rtlCol="0" anchor="t" wrap="square" lIns="96012" rIns="82296" tIns="109728" bIns="41148"/>
+          <a:bodyPr wrap="square" lIns="96012" tIns="109728" rIns="82296" bIns="41148" rtlCol="0" anchor="t"/>
           <a:lstStyle/>
           <a:p>
             <a:pPr algn="l">
@@ -11106,7 +11180,7 @@
                 </a:solidFill>
                 <a:latin typeface="Arial"/>
               </a:rPr>
-              <a:t>Shop Well — client pitch  ·  14</a:t>
+              <a:t>Shop Well — client pitch  ·  16</a:t>
             </a:r>
           </a:p>
         </p:txBody>
@@ -11120,7 +11194,7 @@
 </file>
 
 <file path=ppt/slides/slide15.xml><?xml version="1.0" encoding="utf-8"?>
-<p:sld xmlns:a="http://schemas.openxmlformats.org/drawingml/2006/main" xmlns:p="http://schemas.openxmlformats.org/presentationml/2006/main" xmlns:r="http://schemas.openxmlformats.org/officeDocument/2006/relationships">
+<p:sld xmlns:a="http://schemas.openxmlformats.org/drawingml/2006/main" xmlns:r="http://schemas.openxmlformats.org/officeDocument/2006/relationships" xmlns:p="http://schemas.openxmlformats.org/presentationml/2006/main">
   <p:cSld>
     <p:spTree>
       <p:nvGrpSpPr>
@@ -11128,7 +11202,14 @@
         <p:cNvGrpSpPr/>
         <p:nvPr/>
       </p:nvGrpSpPr>
-      <p:grpSpPr/>
+      <p:grpSpPr>
+        <a:xfrm>
+          <a:off x="0" y="0"/>
+          <a:ext cx="0" cy="0"/>
+          <a:chOff x="0" y="0"/>
+          <a:chExt cx="0" cy="0"/>
+        </a:xfrm>
+      </p:grpSpPr>
       <p:sp>
         <p:nvSpPr>
           <p:cNvPr id="2" name="Rectangle 1"/>
@@ -11170,6 +11251,7 @@
           <a:lstStyle/>
           <a:p>
             <a:pPr algn="ctr"/>
+            <a:endParaRPr/>
           </a:p>
         </p:txBody>
       </p:sp>
@@ -11214,6 +11296,7 @@
           <a:lstStyle/>
           <a:p>
             <a:pPr algn="ctr"/>
+            <a:endParaRPr/>
           </a:p>
         </p:txBody>
       </p:sp>
@@ -11258,6 +11341,7 @@
           <a:lstStyle/>
           <a:p>
             <a:pPr algn="ctr"/>
+            <a:endParaRPr/>
           </a:p>
         </p:txBody>
       </p:sp>
@@ -11302,6 +11386,7 @@
           <a:lstStyle/>
           <a:p>
             <a:pPr algn="ctr"/>
+            <a:endParaRPr/>
           </a:p>
         </p:txBody>
       </p:sp>
@@ -11346,6 +11431,7 @@
           <a:lstStyle/>
           <a:p>
             <a:pPr algn="ctr"/>
+            <a:endParaRPr/>
           </a:p>
         </p:txBody>
       </p:sp>
@@ -11390,6 +11476,7 @@
           <a:lstStyle/>
           <a:p>
             <a:pPr algn="ctr"/>
+            <a:endParaRPr/>
           </a:p>
         </p:txBody>
       </p:sp>
@@ -11434,6 +11521,7 @@
           <a:lstStyle/>
           <a:p>
             <a:pPr algn="ctr"/>
+            <a:endParaRPr/>
           </a:p>
         </p:txBody>
       </p:sp>
@@ -11478,6 +11566,7 @@
           <a:lstStyle/>
           <a:p>
             <a:pPr algn="ctr"/>
+            <a:endParaRPr/>
           </a:p>
         </p:txBody>
       </p:sp>
@@ -11522,6 +11611,7 @@
           <a:lstStyle/>
           <a:p>
             <a:pPr algn="ctr"/>
+            <a:endParaRPr/>
           </a:p>
         </p:txBody>
       </p:sp>
@@ -11566,6 +11656,7 @@
           <a:lstStyle/>
           <a:p>
             <a:pPr algn="ctr"/>
+            <a:endParaRPr/>
           </a:p>
         </p:txBody>
       </p:sp>
@@ -11610,6 +11701,7 @@
           <a:lstStyle/>
           <a:p>
             <a:pPr algn="ctr"/>
+            <a:endParaRPr/>
           </a:p>
         </p:txBody>
       </p:sp>
@@ -11654,6 +11746,7 @@
           <a:lstStyle/>
           <a:p>
             <a:pPr algn="ctr"/>
+            <a:endParaRPr/>
           </a:p>
         </p:txBody>
       </p:sp>
@@ -11698,6 +11791,7 @@
           <a:lstStyle/>
           <a:p>
             <a:pPr algn="ctr"/>
+            <a:endParaRPr/>
           </a:p>
         </p:txBody>
       </p:sp>
@@ -11742,6 +11836,7 @@
           <a:lstStyle/>
           <a:p>
             <a:pPr algn="ctr"/>
+            <a:endParaRPr/>
           </a:p>
         </p:txBody>
       </p:sp>
@@ -11786,6 +11881,7 @@
           <a:lstStyle/>
           <a:p>
             <a:pPr algn="ctr"/>
+            <a:endParaRPr/>
           </a:p>
         </p:txBody>
       </p:sp>
@@ -11830,6 +11926,7 @@
           <a:lstStyle/>
           <a:p>
             <a:pPr algn="ctr"/>
+            <a:endParaRPr/>
           </a:p>
         </p:txBody>
       </p:sp>
@@ -11874,6 +11971,7 @@
           <a:lstStyle/>
           <a:p>
             <a:pPr algn="ctr"/>
+            <a:endParaRPr/>
           </a:p>
         </p:txBody>
       </p:sp>
@@ -11918,6 +12016,7 @@
           <a:lstStyle/>
           <a:p>
             <a:pPr algn="ctr"/>
+            <a:endParaRPr/>
           </a:p>
         </p:txBody>
       </p:sp>
@@ -11962,6 +12061,7 @@
           <a:lstStyle/>
           <a:p>
             <a:pPr algn="ctr"/>
+            <a:endParaRPr/>
           </a:p>
         </p:txBody>
       </p:sp>
@@ -12006,6 +12106,7 @@
           <a:lstStyle/>
           <a:p>
             <a:pPr algn="ctr"/>
+            <a:endParaRPr/>
           </a:p>
         </p:txBody>
       </p:sp>
@@ -12050,6 +12151,7 @@
           <a:lstStyle/>
           <a:p>
             <a:pPr algn="ctr"/>
+            <a:endParaRPr/>
           </a:p>
         </p:txBody>
       </p:sp>
@@ -12094,6 +12196,7 @@
           <a:lstStyle/>
           <a:p>
             <a:pPr algn="ctr"/>
+            <a:endParaRPr/>
           </a:p>
         </p:txBody>
       </p:sp>
@@ -12138,6 +12241,7 @@
           <a:lstStyle/>
           <a:p>
             <a:pPr algn="ctr"/>
+            <a:endParaRPr/>
           </a:p>
         </p:txBody>
       </p:sp>
@@ -12158,7 +12262,7 @@
           <a:noFill/>
         </p:spPr>
         <p:txBody>
-          <a:bodyPr wrap="square" anchor="t" lIns="0" rIns="0" tIns="0" bIns="0">
+          <a:bodyPr wrap="square" lIns="0" tIns="0" rIns="0" bIns="0" anchor="t">
             <a:spAutoFit/>
           </a:bodyPr>
           <a:lstStyle/>
@@ -12260,7 +12364,7 @@
           </a:fontRef>
         </p:style>
         <p:txBody>
-          <a:bodyPr rtlCol="0" anchor="t" wrap="square" lIns="240030" tIns="150876"/>
+          <a:bodyPr wrap="square" lIns="240030" tIns="150876" rtlCol="0" anchor="t"/>
           <a:lstStyle/>
           <a:p>
             <a:pPr algn="l">
@@ -12384,7 +12488,7 @@
                 </a:solidFill>
                 <a:latin typeface="Arial"/>
               </a:rPr>
-              <a:t>Shop Well — client pitch  ·  15</a:t>
+              <a:t>Shop Well — client pitch  ·  17</a:t>
             </a:r>
           </a:p>
         </p:txBody>
@@ -12487,7 +12591,7 @@
 </p:sld>
 </file>
 
-<file path=ppt/slides/slide2.xml><?xml version="1.0" encoding="utf-8"?>
+<file path=ppt/slides/slide17.xml><?xml version="1.0" encoding="utf-8"?>
 <p:sld xmlns:a="http://schemas.openxmlformats.org/drawingml/2006/main" xmlns:p="http://schemas.openxmlformats.org/presentationml/2006/main" xmlns:r="http://schemas.openxmlformats.org/officeDocument/2006/relationships">
   <p:cSld>
     <p:spTree>
@@ -12538,6 +12642,7 @@
           <a:lstStyle/>
           <a:p>
             <a:pPr algn="ctr"/>
+            <a:endParaRPr/>
           </a:p>
         </p:txBody>
       </p:sp>
@@ -12558,7 +12663,7 @@
           <a:noFill/>
         </p:spPr>
         <p:txBody>
-          <a:bodyPr wrap="square" anchor="t" lIns="0" rIns="0" tIns="0" bIns="0">
+          <a:bodyPr wrap="square" lIns="0" tIns="0" rIns="0" bIns="0" anchor="t">
             <a:spAutoFit/>
           </a:bodyPr>
           <a:lstStyle/>
@@ -12578,7 +12683,7 @@
                 </a:solidFill>
                 <a:latin typeface="Arial"/>
               </a:rPr>
-              <a:t>THE PROBLEM</a:t>
+              <a:t>MINI ADM — KEY DATA FLOWS</a:t>
             </a:r>
           </a:p>
           <a:p>
@@ -12597,7 +12702,7 @@
                 </a:solidFill>
                 <a:latin typeface="Arial Black"/>
               </a:rPr>
-              <a:t>Organic food is thriving. Buying it isn't.</a:t>
+              <a:t>What data is created, read and updated</a:t>
             </a:r>
           </a:p>
           <a:p>
@@ -12610,13 +12715,13 @@
               </a:spcAft>
             </a:pPr>
             <a:r>
-              <a:rPr sz="1088" b="0">
+              <a:rPr sz="1088">
                 <a:solidFill>
                   <a:srgbClr val="44655F"/>
                 </a:solidFill>
                 <a:latin typeface="Arial"/>
               </a:rPr>
-              <a:t>What we heard in the client interview on 6 July.</a:t>
+              <a:t>Seven core entities — account, listing, basket, order, shipment, refund, supplier application — and how each step of the journey touches them.</a:t>
             </a:r>
           </a:p>
         </p:txBody>
@@ -12629,8 +12734,8 @@
         </p:nvSpPr>
         <p:spPr>
           <a:xfrm>
-            <a:off x="319925" y="1474470"/>
-            <a:ext cx="2674620" cy="2297430"/>
+            <a:off x="302780" y="1508760"/>
+            <a:ext cx="2708910" cy="1357884"/>
           </a:xfrm>
           <a:prstGeom prst="roundRect">
             <a:avLst>
@@ -12662,7 +12767,7 @@
           </a:fontRef>
         </p:style>
         <p:txBody>
-          <a:bodyPr rtlCol="0" anchor="t" wrap="square" lIns="96012" rIns="82296" tIns="96012" bIns="41148"/>
+          <a:bodyPr wrap="square" lIns="96012" tIns="96012" rIns="82296" bIns="41148" rtlCol="0" anchor="t"/>
           <a:lstStyle/>
           <a:p>
             <a:pPr algn="l">
@@ -12674,13 +12779,13 @@
               </a:spcAft>
             </a:pPr>
             <a:r>
-              <a:rPr sz="1162" b="1">
+              <a:rPr sz="1012" b="1">
                 <a:solidFill>
                   <a:srgbClr val="053238"/>
                 </a:solidFill>
                 <a:latin typeface="Arial"/>
               </a:rPr>
-              <a:t>Customers want traceability</a:t>
+              <a:t>Browse &amp; search</a:t>
             </a:r>
           </a:p>
           <a:p>
@@ -12690,13 +12795,40 @@
               </a:lnSpc>
             </a:pPr>
             <a:r>
-              <a:rPr sz="900">
+              <a:rPr sz="825" b="1">
                 <a:solidFill>
                   <a:srgbClr val="44655F"/>
                 </a:solidFill>
                 <a:latin typeface="Arial"/>
               </a:rPr>
-              <a:t>Shoppers want organic produce and want to know exactly which farm it came from. Today that means juggling separate farm shops, separate baskets, separate deliveries — and separate payments for every single one.</a:t>
+              <a:t>Reads: </a:t>
+            </a:r>
+            <a:r>
+              <a:rPr sz="825">
+                <a:solidFill>
+                  <a:srgbClr val="44655F"/>
+                </a:solidFill>
+                <a:latin typeface="Arial"/>
+              </a:rPr>
+              <a:t>listings — name, price, unit, live stock, supplier, dietary tags — from the catalogue service. </a:t>
+            </a:r>
+            <a:r>
+              <a:rPr sz="825" b="1">
+                <a:solidFill>
+                  <a:srgbClr val="44655F"/>
+                </a:solidFill>
+                <a:latin typeface="Arial"/>
+              </a:rPr>
+              <a:t>Writes: </a:t>
+            </a:r>
+            <a:r>
+              <a:rPr sz="825">
+                <a:solidFill>
+                  <a:srgbClr val="44655F"/>
+                </a:solidFill>
+                <a:latin typeface="Arial"/>
+              </a:rPr>
+              <a:t>nothing.</a:t>
             </a:r>
           </a:p>
         </p:txBody>
@@ -12709,7 +12841,7 @@
         </p:nvSpPr>
         <p:spPr>
           <a:xfrm>
-            <a:off x="415937" y="3662172"/>
+            <a:off x="398792" y="2756915"/>
             <a:ext cx="377190" cy="37719"/>
           </a:xfrm>
           <a:prstGeom prst="rect">
@@ -12742,6 +12874,7 @@
           <a:lstStyle/>
           <a:p>
             <a:pPr algn="ctr"/>
+            <a:endParaRPr/>
           </a:p>
         </p:txBody>
       </p:sp>
@@ -12753,8 +12886,8 @@
         </p:nvSpPr>
         <p:spPr>
           <a:xfrm>
-            <a:off x="3234575" y="1474470"/>
-            <a:ext cx="2674620" cy="2297430"/>
+            <a:off x="3217430" y="1508760"/>
+            <a:ext cx="2708910" cy="1357884"/>
           </a:xfrm>
           <a:prstGeom prst="roundRect">
             <a:avLst>
@@ -12786,7 +12919,7 @@
           </a:fontRef>
         </p:style>
         <p:txBody>
-          <a:bodyPr rtlCol="0" anchor="t" wrap="square" lIns="96012" rIns="82296" tIns="96012" bIns="41148"/>
+          <a:bodyPr wrap="square" lIns="96012" tIns="96012" rIns="82296" bIns="41148" rtlCol="0" anchor="t"/>
           <a:lstStyle/>
           <a:p>
             <a:pPr algn="l">
@@ -12798,13 +12931,13 @@
               </a:spcAft>
             </a:pPr>
             <a:r>
-              <a:rPr sz="1162" b="1">
+              <a:rPr sz="1012" b="1">
                 <a:solidFill>
                   <a:srgbClr val="053238"/>
                 </a:solidFill>
                 <a:latin typeface="Arial"/>
               </a:rPr>
-              <a:t>Small suppliers lack reach</a:t>
+              <a:t>Add to basket</a:t>
             </a:r>
           </a:p>
           <a:p>
@@ -12814,13 +12947,40 @@
               </a:lnSpc>
             </a:pPr>
             <a:r>
-              <a:rPr sz="900">
+              <a:rPr sz="825" b="1">
                 <a:solidFill>
                   <a:srgbClr val="44655F"/>
                 </a:solidFill>
                 <a:latin typeface="Arial"/>
               </a:rPr>
-              <a:t>Independent organic farms rarely have the time or budget for their own online store. On big marketplaces they get buried, lose their identity, and give up control of pricing and stock.</a:t>
+              <a:t>Creates: </a:t>
+            </a:r>
+            <a:r>
+              <a:rPr sz="825">
+                <a:solidFill>
+                  <a:srgbClr val="44655F"/>
+                </a:solidFill>
+                <a:latin typeface="Arial"/>
+              </a:rPr>
+              <a:t>a basket line. </a:t>
+            </a:r>
+            <a:r>
+              <a:rPr sz="825" b="1">
+                <a:solidFill>
+                  <a:srgbClr val="44655F"/>
+                </a:solidFill>
+                <a:latin typeface="Arial"/>
+              </a:rPr>
+              <a:t>Reads: </a:t>
+            </a:r>
+            <a:r>
+              <a:rPr sz="825">
+                <a:solidFill>
+                  <a:srgbClr val="44655F"/>
+                </a:solidFill>
+                <a:latin typeface="Arial"/>
+              </a:rPr>
+              <a:t>live stock — the stock service caps every quantity at what is really available.</a:t>
             </a:r>
           </a:p>
         </p:txBody>
@@ -12833,7 +12993,7 @@
         </p:nvSpPr>
         <p:spPr>
           <a:xfrm>
-            <a:off x="3330587" y="3662172"/>
+            <a:off x="3313442" y="2756915"/>
             <a:ext cx="377190" cy="37719"/>
           </a:xfrm>
           <a:prstGeom prst="rect">
@@ -12866,6 +13026,7 @@
           <a:lstStyle/>
           <a:p>
             <a:pPr algn="ctr"/>
+            <a:endParaRPr/>
           </a:p>
         </p:txBody>
       </p:sp>
@@ -12877,8 +13038,8 @@
         </p:nvSpPr>
         <p:spPr>
           <a:xfrm>
-            <a:off x="6149225" y="1474470"/>
-            <a:ext cx="2674620" cy="2297430"/>
+            <a:off x="6132080" y="1508760"/>
+            <a:ext cx="2708910" cy="1357884"/>
           </a:xfrm>
           <a:prstGeom prst="roundRect">
             <a:avLst>
@@ -12910,7 +13071,7 @@
           </a:fontRef>
         </p:style>
         <p:txBody>
-          <a:bodyPr rtlCol="0" anchor="t" wrap="square" lIns="96012" rIns="82296" tIns="96012" bIns="41148"/>
+          <a:bodyPr wrap="square" lIns="96012" tIns="96012" rIns="82296" bIns="41148" rtlCol="0" anchor="t"/>
           <a:lstStyle/>
           <a:p>
             <a:pPr algn="l">
@@ -12922,13 +13083,13 @@
               </a:spcAft>
             </a:pPr>
             <a:r>
-              <a:rPr sz="1162" b="1">
+              <a:rPr sz="1012" b="1">
                 <a:solidFill>
                   <a:srgbClr val="053238"/>
                 </a:solidFill>
                 <a:latin typeface="Arial"/>
               </a:rPr>
-              <a:t>Nobody joins the two</a:t>
+              <a:t>Checkout &amp; pay</a:t>
             </a:r>
           </a:p>
           <a:p>
@@ -12938,13 +13099,49 @@
               </a:lnSpc>
             </a:pPr>
             <a:r>
-              <a:rPr sz="900">
+              <a:rPr sz="825" b="1">
                 <a:solidFill>
                   <a:srgbClr val="44655F"/>
                 </a:solidFill>
                 <a:latin typeface="Arial"/>
               </a:rPr>
-              <a:t>There is no UK marketplace where one basket can span many vetted organic farms with a single checkout — while each farm still ships its own produce and keeps its own brand front and centre.</a:t>
+              <a:t>Creates: </a:t>
+            </a:r>
+            <a:r>
+              <a:rPr sz="825">
+                <a:solidFill>
+                  <a:srgbClr val="44655F"/>
+                </a:solidFill>
+                <a:latin typeface="Arial"/>
+              </a:rPr>
+              <a:t>the order and its per-supplier shipments. </a:t>
+            </a:r>
+            <a:r>
+              <a:rPr sz="825" b="1">
+                <a:solidFill>
+                  <a:srgbClr val="44655F"/>
+                </a:solidFill>
+                <a:latin typeface="Arial"/>
+              </a:rPr>
+              <a:t>Reads: </a:t>
+            </a:r>
+            <a:r>
+              <a:rPr sz="825">
+                <a:solidFill>
+                  <a:srgbClr val="44655F"/>
+                </a:solidFill>
+                <a:latin typeface="Arial"/>
+              </a:rPr>
+              <a:t>account details to prefill. </a:t>
+            </a:r>
+            <a:r>
+              <a:rPr sz="825">
+                <a:solidFill>
+                  <a:srgbClr val="44655F"/>
+                </a:solidFill>
+                <a:latin typeface="Arial"/>
+              </a:rPr>
+              <a:t>Card data lives only with the payment provider.</a:t>
             </a:r>
           </a:p>
         </p:txBody>
@@ -12957,7 +13154,7 @@
         </p:nvSpPr>
         <p:spPr>
           <a:xfrm>
-            <a:off x="6245237" y="3662172"/>
+            <a:off x="6228092" y="2756915"/>
             <a:ext cx="377190" cy="37719"/>
           </a:xfrm>
           <a:prstGeom prst="rect">
@@ -12990,6 +13187,7 @@
           <a:lstStyle/>
           <a:p>
             <a:pPr algn="ctr"/>
+            <a:endParaRPr/>
           </a:p>
         </p:txBody>
       </p:sp>
@@ -13001,13 +13199,118 @@
         </p:nvSpPr>
         <p:spPr>
           <a:xfrm>
-            <a:off x="2311146" y="4080510"/>
-            <a:ext cx="4526280" cy="342900"/>
+            <a:off x="302780" y="3106674"/>
+            <a:ext cx="2708910" cy="1357884"/>
           </a:xfrm>
           <a:prstGeom prst="roundRect">
             <a:avLst>
-              <a:gd name="adj" fmla="val 50000"/>
+              <a:gd name="adj" fmla="val 8000"/>
             </a:avLst>
+          </a:prstGeom>
+          <a:solidFill>
+            <a:srgbClr val="FFFFFF"/>
+          </a:solidFill>
+          <a:ln w="11906">
+            <a:solidFill>
+              <a:srgbClr val="D4E8DC"/>
+            </a:solidFill>
+          </a:ln>
+          <a:effectLst/>
+        </p:spPr>
+        <p:style>
+          <a:lnRef idx="1">
+            <a:schemeClr val="accent1"/>
+          </a:lnRef>
+          <a:fillRef idx="3">
+            <a:schemeClr val="accent1"/>
+          </a:fillRef>
+          <a:effectRef idx="2">
+            <a:schemeClr val="accent1"/>
+          </a:effectRef>
+          <a:fontRef idx="minor">
+            <a:schemeClr val="lt1"/>
+          </a:fontRef>
+        </p:style>
+        <p:txBody>
+          <a:bodyPr wrap="square" lIns="96012" tIns="96012" rIns="82296" bIns="41148" rtlCol="0" anchor="t"/>
+          <a:lstStyle/>
+          <a:p>
+            <a:pPr algn="l">
+              <a:lnSpc>
+                <a:spcPct val="105000"/>
+              </a:lnSpc>
+              <a:spcAft>
+                <a:spcPts val="225"/>
+              </a:spcAft>
+            </a:pPr>
+            <a:r>
+              <a:rPr sz="1012" b="1">
+                <a:solidFill>
+                  <a:srgbClr val="053238"/>
+                </a:solidFill>
+                <a:latin typeface="Arial"/>
+              </a:rPr>
+              <a:t>Fulfil &amp; track</a:t>
+            </a:r>
+          </a:p>
+          <a:p>
+            <a:pPr algn="l">
+              <a:lnSpc>
+                <a:spcPct val="105000"/>
+              </a:lnSpc>
+            </a:pPr>
+            <a:r>
+              <a:rPr sz="825" b="1">
+                <a:solidFill>
+                  <a:srgbClr val="44655F"/>
+                </a:solidFill>
+                <a:latin typeface="Arial"/>
+              </a:rPr>
+              <a:t>Updates: </a:t>
+            </a:r>
+            <a:r>
+              <a:rPr sz="825">
+                <a:solidFill>
+                  <a:srgbClr val="44655F"/>
+                </a:solidFill>
+                <a:latin typeface="Arial"/>
+              </a:rPr>
+              <a:t>shipment status — Placed, Packed, Shipped, Delivered — and </a:t>
+            </a:r>
+            <a:r>
+              <a:rPr sz="825" b="1">
+                <a:solidFill>
+                  <a:srgbClr val="44655F"/>
+                </a:solidFill>
+                <a:latin typeface="Arial"/>
+              </a:rPr>
+              <a:t>creates </a:t>
+            </a:r>
+            <a:r>
+              <a:rPr sz="825">
+                <a:solidFill>
+                  <a:srgbClr val="44655F"/>
+                </a:solidFill>
+                <a:latin typeface="Arial"/>
+              </a:rPr>
+              <a:t>the tracking number. Suppliers read only their own orders.</a:t>
+            </a:r>
+          </a:p>
+        </p:txBody>
+      </p:sp>
+      <p:sp>
+        <p:nvSpPr>
+          <p:cNvPr id="11" name="Rectangle 10"/>
+          <p:cNvSpPr/>
+          <p:nvPr/>
+        </p:nvSpPr>
+        <p:spPr>
+          <a:xfrm>
+            <a:off x="398792" y="4354830"/>
+            <a:ext cx="377190" cy="37719"/>
+          </a:xfrm>
+          <a:prstGeom prst="rect">
+            <a:avLst/>
           </a:prstGeom>
           <a:solidFill>
             <a:srgbClr val="940758"/>
@@ -13032,25 +13335,303 @@
           </a:fontRef>
         </p:style>
         <p:txBody>
-          <a:bodyPr rtlCol="0" anchor="ctr" wrap="square" lIns="82296" rIns="82296" tIns="0" bIns="0"/>
+          <a:bodyPr rtlCol="0" anchor="ctr"/>
           <a:lstStyle/>
           <a:p>
             <a:pPr algn="ctr"/>
-            <a:r>
-              <a:rPr sz="975" b="1">
-                <a:solidFill>
-                  <a:srgbClr val="FFFFFF"/>
-                </a:solidFill>
-                <a:latin typeface="Arial"/>
-              </a:rPr>
-              <a:t>The gap in the market is the connection — that's Shop Well.</a:t>
-            </a:r>
-          </a:p>
-        </p:txBody>
-      </p:sp>
-      <p:sp>
-        <p:nvSpPr>
-          <p:cNvPr id="11" name="TextBox 10"/>
+            <a:endParaRPr/>
+          </a:p>
+        </p:txBody>
+      </p:sp>
+      <p:sp>
+        <p:nvSpPr>
+          <p:cNvPr id="12" name="Rounded Rectangle 11"/>
+          <p:cNvSpPr/>
+          <p:nvPr/>
+        </p:nvSpPr>
+        <p:spPr>
+          <a:xfrm>
+            <a:off x="3217430" y="3106674"/>
+            <a:ext cx="2708910" cy="1357884"/>
+          </a:xfrm>
+          <a:prstGeom prst="roundRect">
+            <a:avLst>
+              <a:gd name="adj" fmla="val 8000"/>
+            </a:avLst>
+          </a:prstGeom>
+          <a:solidFill>
+            <a:srgbClr val="FFFFFF"/>
+          </a:solidFill>
+          <a:ln w="11906">
+            <a:solidFill>
+              <a:srgbClr val="D4E8DC"/>
+            </a:solidFill>
+          </a:ln>
+          <a:effectLst/>
+        </p:spPr>
+        <p:style>
+          <a:lnRef idx="1">
+            <a:schemeClr val="accent1"/>
+          </a:lnRef>
+          <a:fillRef idx="3">
+            <a:schemeClr val="accent1"/>
+          </a:fillRef>
+          <a:effectRef idx="2">
+            <a:schemeClr val="accent1"/>
+          </a:effectRef>
+          <a:fontRef idx="minor">
+            <a:schemeClr val="lt1"/>
+          </a:fontRef>
+        </p:style>
+        <p:txBody>
+          <a:bodyPr wrap="square" lIns="96012" tIns="96012" rIns="82296" bIns="41148" rtlCol="0" anchor="t"/>
+          <a:lstStyle/>
+          <a:p>
+            <a:pPr algn="l">
+              <a:lnSpc>
+                <a:spcPct val="105000"/>
+              </a:lnSpc>
+              <a:spcAft>
+                <a:spcPts val="225"/>
+              </a:spcAft>
+            </a:pPr>
+            <a:r>
+              <a:rPr sz="1012" b="1">
+                <a:solidFill>
+                  <a:srgbClr val="053238"/>
+                </a:solidFill>
+                <a:latin typeface="Arial"/>
+              </a:rPr>
+              <a:t>Refund</a:t>
+            </a:r>
+          </a:p>
+          <a:p>
+            <a:pPr algn="l">
+              <a:lnSpc>
+                <a:spcPct val="105000"/>
+              </a:lnSpc>
+            </a:pPr>
+            <a:r>
+              <a:rPr sz="825" b="1">
+                <a:solidFill>
+                  <a:srgbClr val="44655F"/>
+                </a:solidFill>
+                <a:latin typeface="Arial"/>
+              </a:rPr>
+              <a:t>Updates: </a:t>
+            </a:r>
+            <a:r>
+              <a:rPr sz="825">
+                <a:solidFill>
+                  <a:srgbClr val="44655F"/>
+                </a:solidFill>
+                <a:latin typeface="Arial"/>
+              </a:rPr>
+              <a:t>order total, shipment status and the supplier's fulfilment flag in one routine, so the three can never disagree.</a:t>
+            </a:r>
+          </a:p>
+        </p:txBody>
+      </p:sp>
+      <p:sp>
+        <p:nvSpPr>
+          <p:cNvPr id="13" name="Rectangle 12"/>
+          <p:cNvSpPr/>
+          <p:nvPr/>
+        </p:nvSpPr>
+        <p:spPr>
+          <a:xfrm>
+            <a:off x="3313442" y="4354830"/>
+            <a:ext cx="377190" cy="37719"/>
+          </a:xfrm>
+          <a:prstGeom prst="rect">
+            <a:avLst/>
+          </a:prstGeom>
+          <a:solidFill>
+            <a:srgbClr val="940758"/>
+          </a:solidFill>
+          <a:ln>
+            <a:noFill/>
+          </a:ln>
+          <a:effectLst/>
+        </p:spPr>
+        <p:style>
+          <a:lnRef idx="1">
+            <a:schemeClr val="accent1"/>
+          </a:lnRef>
+          <a:fillRef idx="3">
+            <a:schemeClr val="accent1"/>
+          </a:fillRef>
+          <a:effectRef idx="2">
+            <a:schemeClr val="accent1"/>
+          </a:effectRef>
+          <a:fontRef idx="minor">
+            <a:schemeClr val="lt1"/>
+          </a:fontRef>
+        </p:style>
+        <p:txBody>
+          <a:bodyPr rtlCol="0" anchor="ctr"/>
+          <a:lstStyle/>
+          <a:p>
+            <a:pPr algn="ctr"/>
+            <a:endParaRPr/>
+          </a:p>
+        </p:txBody>
+      </p:sp>
+      <p:sp>
+        <p:nvSpPr>
+          <p:cNvPr id="14" name="Rounded Rectangle 13"/>
+          <p:cNvSpPr/>
+          <p:nvPr/>
+        </p:nvSpPr>
+        <p:spPr>
+          <a:xfrm>
+            <a:off x="6132080" y="3106674"/>
+            <a:ext cx="2708910" cy="1357884"/>
+          </a:xfrm>
+          <a:prstGeom prst="roundRect">
+            <a:avLst>
+              <a:gd name="adj" fmla="val 8000"/>
+            </a:avLst>
+          </a:prstGeom>
+          <a:solidFill>
+            <a:srgbClr val="FFFFFF"/>
+          </a:solidFill>
+          <a:ln w="11906">
+            <a:solidFill>
+              <a:srgbClr val="D4E8DC"/>
+            </a:solidFill>
+          </a:ln>
+          <a:effectLst/>
+        </p:spPr>
+        <p:style>
+          <a:lnRef idx="1">
+            <a:schemeClr val="accent1"/>
+          </a:lnRef>
+          <a:fillRef idx="3">
+            <a:schemeClr val="accent1"/>
+          </a:fillRef>
+          <a:effectRef idx="2">
+            <a:schemeClr val="accent1"/>
+          </a:effectRef>
+          <a:fontRef idx="minor">
+            <a:schemeClr val="lt1"/>
+          </a:fontRef>
+        </p:style>
+        <p:txBody>
+          <a:bodyPr wrap="square" lIns="96012" tIns="96012" rIns="82296" bIns="41148" rtlCol="0" anchor="t"/>
+          <a:lstStyle/>
+          <a:p>
+            <a:pPr algn="l">
+              <a:lnSpc>
+                <a:spcPct val="105000"/>
+              </a:lnSpc>
+              <a:spcAft>
+                <a:spcPts val="225"/>
+              </a:spcAft>
+            </a:pPr>
+            <a:r>
+              <a:rPr sz="1012" b="1">
+                <a:solidFill>
+                  <a:srgbClr val="053238"/>
+                </a:solidFill>
+                <a:latin typeface="Arial"/>
+              </a:rPr>
+              <a:t>'Ask Shop Well' support</a:t>
+            </a:r>
+          </a:p>
+          <a:p>
+            <a:pPr algn="l">
+              <a:lnSpc>
+                <a:spcPct val="105000"/>
+              </a:lnSpc>
+            </a:pPr>
+            <a:r>
+              <a:rPr sz="825" b="1">
+                <a:solidFill>
+                  <a:srgbClr val="44655F"/>
+                </a:solidFill>
+                <a:latin typeface="Arial"/>
+              </a:rPr>
+              <a:t>Reads: </a:t>
+            </a:r>
+            <a:r>
+              <a:rPr sz="825">
+                <a:solidFill>
+                  <a:srgbClr val="44655F"/>
+                </a:solidFill>
+                <a:latin typeface="Arial"/>
+              </a:rPr>
+              <a:t>live orders — strictly read-only. </a:t>
+            </a:r>
+            <a:r>
+              <a:rPr sz="825" b="1">
+                <a:solidFill>
+                  <a:srgbClr val="44655F"/>
+                </a:solidFill>
+                <a:latin typeface="Arial"/>
+              </a:rPr>
+              <a:t>Creates: </a:t>
+            </a:r>
+            <a:r>
+              <a:rPr sz="825">
+                <a:solidFill>
+                  <a:srgbClr val="44655F"/>
+                </a:solidFill>
+                <a:latin typeface="Arial"/>
+              </a:rPr>
+              <a:t>an escalation ticket with full context when a human needs to step in.</a:t>
+            </a:r>
+          </a:p>
+        </p:txBody>
+      </p:sp>
+      <p:sp>
+        <p:nvSpPr>
+          <p:cNvPr id="15" name="Rectangle 14"/>
+          <p:cNvSpPr/>
+          <p:nvPr/>
+        </p:nvSpPr>
+        <p:spPr>
+          <a:xfrm>
+            <a:off x="6228092" y="4354830"/>
+            <a:ext cx="377190" cy="37719"/>
+          </a:xfrm>
+          <a:prstGeom prst="rect">
+            <a:avLst/>
+          </a:prstGeom>
+          <a:solidFill>
+            <a:srgbClr val="940758"/>
+          </a:solidFill>
+          <a:ln>
+            <a:noFill/>
+          </a:ln>
+          <a:effectLst/>
+        </p:spPr>
+        <p:style>
+          <a:lnRef idx="1">
+            <a:schemeClr val="accent1"/>
+          </a:lnRef>
+          <a:fillRef idx="3">
+            <a:schemeClr val="accent1"/>
+          </a:fillRef>
+          <a:effectRef idx="2">
+            <a:schemeClr val="accent1"/>
+          </a:effectRef>
+          <a:fontRef idx="minor">
+            <a:schemeClr val="lt1"/>
+          </a:fontRef>
+        </p:style>
+        <p:txBody>
+          <a:bodyPr rtlCol="0" anchor="ctr"/>
+          <a:lstStyle/>
+          <a:p>
+            <a:pPr algn="ctr"/>
+            <a:endParaRPr/>
+          </a:p>
+        </p:txBody>
+      </p:sp>
+      <p:sp>
+        <p:nvSpPr>
+          <p:cNvPr id="16" name="TextBox 15"/>
           <p:cNvSpPr txBox="1"/>
           <p:nvPr/>
         </p:nvSpPr>
@@ -13077,7 +13658,1727 @@
                 </a:solidFill>
                 <a:latin typeface="Arial"/>
               </a:rPr>
-              <a:t>Shop Well — client pitch  ·  2</a:t>
+              <a:t>Shop Well — client pitch  ·  9</a:t>
+            </a:r>
+          </a:p>
+        </p:txBody>
+      </p:sp>
+    </p:spTree>
+  </p:cSld>
+  <p:clrMapOvr>
+    <a:masterClrMapping/>
+  </p:clrMapOvr>
+</p:sld>
+</file>
+
+<file path=ppt/slides/slide18.xml><?xml version="1.0" encoding="utf-8"?>
+<p:sld xmlns:a="http://schemas.openxmlformats.org/drawingml/2006/main" xmlns:p="http://schemas.openxmlformats.org/presentationml/2006/main" xmlns:r="http://schemas.openxmlformats.org/officeDocument/2006/relationships">
+  <p:cSld>
+    <p:spTree>
+      <p:nvGrpSpPr>
+        <p:cNvPr id="1" name=""/>
+        <p:cNvGrpSpPr/>
+        <p:nvPr/>
+      </p:nvGrpSpPr>
+      <p:grpSpPr/>
+      <p:sp>
+        <p:nvSpPr>
+          <p:cNvPr id="2" name="Rectangle 1"/>
+          <p:cNvSpPr/>
+          <p:nvPr/>
+        </p:nvSpPr>
+        <p:spPr>
+          <a:xfrm>
+            <a:off x="0" y="0"/>
+            <a:ext cx="9143771" cy="5143500"/>
+          </a:xfrm>
+          <a:prstGeom prst="rect">
+            <a:avLst/>
+          </a:prstGeom>
+          <a:solidFill>
+            <a:srgbClr val="F2F8F3"/>
+          </a:solidFill>
+          <a:ln>
+            <a:noFill/>
+          </a:ln>
+          <a:effectLst/>
+        </p:spPr>
+        <p:style>
+          <a:lnRef idx="1">
+            <a:schemeClr val="accent1"/>
+          </a:lnRef>
+          <a:fillRef idx="3">
+            <a:schemeClr val="accent1"/>
+          </a:fillRef>
+          <a:effectRef idx="2">
+            <a:schemeClr val="accent1"/>
+          </a:effectRef>
+          <a:fontRef idx="minor">
+            <a:schemeClr val="lt1"/>
+          </a:fontRef>
+        </p:style>
+        <p:txBody>
+          <a:bodyPr rtlCol="0" anchor="ctr"/>
+          <a:lstStyle/>
+          <a:p>
+            <a:pPr algn="ctr"/>
+            <a:endParaRPr/>
+          </a:p>
+        </p:txBody>
+      </p:sp>
+      <p:sp>
+        <p:nvSpPr>
+          <p:cNvPr id="3" name="TextBox 2"/>
+          <p:cNvSpPr txBox="1"/>
+          <p:nvPr/>
+        </p:nvSpPr>
+        <p:spPr>
+          <a:xfrm>
+            <a:off x="377190" y="288036"/>
+            <a:ext cx="8366760" cy="994410"/>
+          </a:xfrm>
+          <a:prstGeom prst="rect">
+            <a:avLst/>
+          </a:prstGeom>
+          <a:noFill/>
+        </p:spPr>
+        <p:txBody>
+          <a:bodyPr wrap="square" lIns="0" tIns="0" rIns="0" bIns="0" anchor="t">
+            <a:spAutoFit/>
+          </a:bodyPr>
+          <a:lstStyle/>
+          <a:p>
+            <a:pPr algn="l">
+              <a:lnSpc>
+                <a:spcPct val="108000"/>
+              </a:lnSpc>
+              <a:spcAft>
+                <a:spcPts val="450"/>
+              </a:spcAft>
+            </a:pPr>
+            <a:r>
+              <a:rPr sz="938" b="1">
+                <a:solidFill>
+                  <a:srgbClr val="940758"/>
+                </a:solidFill>
+                <a:latin typeface="Arial"/>
+              </a:rPr>
+              <a:t>MAIN RISKS &amp; FIXES</a:t>
+            </a:r>
+          </a:p>
+          <a:p>
+            <a:pPr algn="l">
+              <a:lnSpc>
+                <a:spcPct val="108000"/>
+              </a:lnSpc>
+              <a:spcAft>
+                <a:spcPts val="300"/>
+              </a:spcAft>
+            </a:pPr>
+            <a:r>
+              <a:rPr sz="2325" b="1">
+                <a:solidFill>
+                  <a:srgbClr val="053238"/>
+                </a:solidFill>
+                <a:latin typeface="Arial Black"/>
+              </a:rPr>
+              <a:t>What could break — and what we changed</a:t>
+            </a:r>
+          </a:p>
+          <a:p>
+            <a:pPr algn="l">
+              <a:lnSpc>
+                <a:spcPct val="108000"/>
+              </a:lnSpc>
+              <a:spcAft>
+                <a:spcPts val="0"/>
+              </a:spcAft>
+            </a:pPr>
+            <a:r>
+              <a:rPr sz="1088">
+                <a:solidFill>
+                  <a:srgbClr val="44655F"/>
+                </a:solidFill>
+                <a:latin typeface="Arial"/>
+              </a:rPr>
+              <a:t>Every fix on this slide is already in the build — none of it is a promise.</a:t>
+            </a:r>
+          </a:p>
+        </p:txBody>
+      </p:sp>
+      <p:sp>
+        <p:nvSpPr>
+          <p:cNvPr id="4" name="Rounded Rectangle 3"/>
+          <p:cNvSpPr/>
+          <p:nvPr/>
+        </p:nvSpPr>
+        <p:spPr>
+          <a:xfrm>
+            <a:off x="302780" y="1508760"/>
+            <a:ext cx="2708910" cy="1357884"/>
+          </a:xfrm>
+          <a:prstGeom prst="roundRect">
+            <a:avLst>
+              <a:gd name="adj" fmla="val 8000"/>
+            </a:avLst>
+          </a:prstGeom>
+          <a:solidFill>
+            <a:srgbClr val="FFFFFF"/>
+          </a:solidFill>
+          <a:ln w="11906">
+            <a:solidFill>
+              <a:srgbClr val="D4E8DC"/>
+            </a:solidFill>
+          </a:ln>
+          <a:effectLst/>
+        </p:spPr>
+        <p:style>
+          <a:lnRef idx="1">
+            <a:schemeClr val="accent1"/>
+          </a:lnRef>
+          <a:fillRef idx="3">
+            <a:schemeClr val="accent1"/>
+          </a:fillRef>
+          <a:effectRef idx="2">
+            <a:schemeClr val="accent1"/>
+          </a:effectRef>
+          <a:fontRef idx="minor">
+            <a:schemeClr val="lt1"/>
+          </a:fontRef>
+        </p:style>
+        <p:txBody>
+          <a:bodyPr wrap="square" lIns="96012" tIns="96012" rIns="82296" bIns="41148" rtlCol="0" anchor="t"/>
+          <a:lstStyle/>
+          <a:p>
+            <a:pPr algn="l">
+              <a:lnSpc>
+                <a:spcPct val="105000"/>
+              </a:lnSpc>
+              <a:spcAft>
+                <a:spcPts val="225"/>
+              </a:spcAft>
+            </a:pPr>
+            <a:r>
+              <a:rPr sz="1012" b="1">
+                <a:solidFill>
+                  <a:srgbClr val="053238"/>
+                </a:solidFill>
+                <a:latin typeface="Arial"/>
+              </a:rPr>
+              <a:t>Overselling stock</a:t>
+            </a:r>
+          </a:p>
+          <a:p>
+            <a:pPr algn="l">
+              <a:lnSpc>
+                <a:spcPct val="105000"/>
+              </a:lnSpc>
+            </a:pPr>
+            <a:r>
+              <a:rPr sz="825" b="1">
+                <a:solidFill>
+                  <a:srgbClr val="44655F"/>
+                </a:solidFill>
+                <a:latin typeface="Arial"/>
+              </a:rPr>
+              <a:t>Risk: </a:t>
+            </a:r>
+            <a:r>
+              <a:rPr sz="825">
+                <a:solidFill>
+                  <a:srgbClr val="44655F"/>
+                </a:solidFill>
+                <a:latin typeface="Arial"/>
+              </a:rPr>
+              <a:t>two shoppers buy the last crate. </a:t>
+            </a:r>
+            <a:r>
+              <a:rPr sz="825" b="1">
+                <a:solidFill>
+                  <a:srgbClr val="44655F"/>
+                </a:solidFill>
+                <a:latin typeface="Arial"/>
+              </a:rPr>
+              <a:t>Fix: </a:t>
+            </a:r>
+            <a:r>
+              <a:rPr sz="825">
+                <a:solidFill>
+                  <a:srgbClr val="44655F"/>
+                </a:solidFill>
+                <a:latin typeface="Arial"/>
+              </a:rPr>
+              <a:t>stock is enforced three times — basket guard, quantity cap, final checkout re-check.</a:t>
+            </a:r>
+          </a:p>
+        </p:txBody>
+      </p:sp>
+      <p:sp>
+        <p:nvSpPr>
+          <p:cNvPr id="5" name="Rectangle 4"/>
+          <p:cNvSpPr/>
+          <p:nvPr/>
+        </p:nvSpPr>
+        <p:spPr>
+          <a:xfrm>
+            <a:off x="398792" y="2756915"/>
+            <a:ext cx="377190" cy="37719"/>
+          </a:xfrm>
+          <a:prstGeom prst="rect">
+            <a:avLst/>
+          </a:prstGeom>
+          <a:solidFill>
+            <a:srgbClr val="940758"/>
+          </a:solidFill>
+          <a:ln>
+            <a:noFill/>
+          </a:ln>
+          <a:effectLst/>
+        </p:spPr>
+        <p:style>
+          <a:lnRef idx="1">
+            <a:schemeClr val="accent1"/>
+          </a:lnRef>
+          <a:fillRef idx="3">
+            <a:schemeClr val="accent1"/>
+          </a:fillRef>
+          <a:effectRef idx="2">
+            <a:schemeClr val="accent1"/>
+          </a:effectRef>
+          <a:fontRef idx="minor">
+            <a:schemeClr val="lt1"/>
+          </a:fontRef>
+        </p:style>
+        <p:txBody>
+          <a:bodyPr rtlCol="0" anchor="ctr"/>
+          <a:lstStyle/>
+          <a:p>
+            <a:pPr algn="ctr"/>
+            <a:endParaRPr/>
+          </a:p>
+        </p:txBody>
+      </p:sp>
+      <p:sp>
+        <p:nvSpPr>
+          <p:cNvPr id="6" name="Rounded Rectangle 5"/>
+          <p:cNvSpPr/>
+          <p:nvPr/>
+        </p:nvSpPr>
+        <p:spPr>
+          <a:xfrm>
+            <a:off x="3217430" y="1508760"/>
+            <a:ext cx="2708910" cy="1357884"/>
+          </a:xfrm>
+          <a:prstGeom prst="roundRect">
+            <a:avLst>
+              <a:gd name="adj" fmla="val 8000"/>
+            </a:avLst>
+          </a:prstGeom>
+          <a:solidFill>
+            <a:srgbClr val="FFFFFF"/>
+          </a:solidFill>
+          <a:ln w="11906">
+            <a:solidFill>
+              <a:srgbClr val="D4E8DC"/>
+            </a:solidFill>
+          </a:ln>
+          <a:effectLst/>
+        </p:spPr>
+        <p:style>
+          <a:lnRef idx="1">
+            <a:schemeClr val="accent1"/>
+          </a:lnRef>
+          <a:fillRef idx="3">
+            <a:schemeClr val="accent1"/>
+          </a:fillRef>
+          <a:effectRef idx="2">
+            <a:schemeClr val="accent1"/>
+          </a:effectRef>
+          <a:fontRef idx="minor">
+            <a:schemeClr val="lt1"/>
+          </a:fontRef>
+        </p:style>
+        <p:txBody>
+          <a:bodyPr wrap="square" lIns="96012" tIns="96012" rIns="82296" bIns="41148" rtlCol="0" anchor="t"/>
+          <a:lstStyle/>
+          <a:p>
+            <a:pPr algn="l">
+              <a:lnSpc>
+                <a:spcPct val="105000"/>
+              </a:lnSpc>
+              <a:spcAft>
+                <a:spcPts val="225"/>
+              </a:spcAft>
+            </a:pPr>
+            <a:r>
+              <a:rPr sz="1012" b="1">
+                <a:solidFill>
+                  <a:srgbClr val="053238"/>
+                </a:solidFill>
+                <a:latin typeface="Arial"/>
+              </a:rPr>
+              <a:t>Card data breach</a:t>
+            </a:r>
+          </a:p>
+          <a:p>
+            <a:pPr algn="l">
+              <a:lnSpc>
+                <a:spcPct val="105000"/>
+              </a:lnSpc>
+            </a:pPr>
+            <a:r>
+              <a:rPr sz="825" b="1">
+                <a:solidFill>
+                  <a:srgbClr val="44655F"/>
+                </a:solidFill>
+                <a:latin typeface="Arial"/>
+              </a:rPr>
+              <a:t>Risk: </a:t>
+            </a:r>
+            <a:r>
+              <a:rPr sz="825">
+                <a:solidFill>
+                  <a:srgbClr val="44655F"/>
+                </a:solidFill>
+                <a:latin typeface="Arial"/>
+              </a:rPr>
+              <a:t>holding card numbers we cannot protect. </a:t>
+            </a:r>
+            <a:r>
+              <a:rPr sz="825" b="1">
+                <a:solidFill>
+                  <a:srgbClr val="44655F"/>
+                </a:solidFill>
+                <a:latin typeface="Arial"/>
+              </a:rPr>
+              <a:t>Fix: </a:t>
+            </a:r>
+            <a:r>
+              <a:rPr sz="825">
+                <a:solidFill>
+                  <a:srgbClr val="44655F"/>
+                </a:solidFill>
+                <a:latin typeface="Arial"/>
+              </a:rPr>
+              <a:t>the payment provider keeps all card data — it never touches Shop Well.</a:t>
+            </a:r>
+          </a:p>
+        </p:txBody>
+      </p:sp>
+      <p:sp>
+        <p:nvSpPr>
+          <p:cNvPr id="7" name="Rectangle 6"/>
+          <p:cNvSpPr/>
+          <p:nvPr/>
+        </p:nvSpPr>
+        <p:spPr>
+          <a:xfrm>
+            <a:off x="3313442" y="2756915"/>
+            <a:ext cx="377190" cy="37719"/>
+          </a:xfrm>
+          <a:prstGeom prst="rect">
+            <a:avLst/>
+          </a:prstGeom>
+          <a:solidFill>
+            <a:srgbClr val="940758"/>
+          </a:solidFill>
+          <a:ln>
+            <a:noFill/>
+          </a:ln>
+          <a:effectLst/>
+        </p:spPr>
+        <p:style>
+          <a:lnRef idx="1">
+            <a:schemeClr val="accent1"/>
+          </a:lnRef>
+          <a:fillRef idx="3">
+            <a:schemeClr val="accent1"/>
+          </a:fillRef>
+          <a:effectRef idx="2">
+            <a:schemeClr val="accent1"/>
+          </a:effectRef>
+          <a:fontRef idx="minor">
+            <a:schemeClr val="lt1"/>
+          </a:fontRef>
+        </p:style>
+        <p:txBody>
+          <a:bodyPr rtlCol="0" anchor="ctr"/>
+          <a:lstStyle/>
+          <a:p>
+            <a:pPr algn="ctr"/>
+            <a:endParaRPr/>
+          </a:p>
+        </p:txBody>
+      </p:sp>
+      <p:sp>
+        <p:nvSpPr>
+          <p:cNvPr id="8" name="Rounded Rectangle 7"/>
+          <p:cNvSpPr/>
+          <p:nvPr/>
+        </p:nvSpPr>
+        <p:spPr>
+          <a:xfrm>
+            <a:off x="6132080" y="1508760"/>
+            <a:ext cx="2708910" cy="1357884"/>
+          </a:xfrm>
+          <a:prstGeom prst="roundRect">
+            <a:avLst>
+              <a:gd name="adj" fmla="val 8000"/>
+            </a:avLst>
+          </a:prstGeom>
+          <a:solidFill>
+            <a:srgbClr val="FFFFFF"/>
+          </a:solidFill>
+          <a:ln w="11906">
+            <a:solidFill>
+              <a:srgbClr val="D4E8DC"/>
+            </a:solidFill>
+          </a:ln>
+          <a:effectLst/>
+        </p:spPr>
+        <p:style>
+          <a:lnRef idx="1">
+            <a:schemeClr val="accent1"/>
+          </a:lnRef>
+          <a:fillRef idx="3">
+            <a:schemeClr val="accent1"/>
+          </a:fillRef>
+          <a:effectRef idx="2">
+            <a:schemeClr val="accent1"/>
+          </a:effectRef>
+          <a:fontRef idx="minor">
+            <a:schemeClr val="lt1"/>
+          </a:fontRef>
+        </p:style>
+        <p:txBody>
+          <a:bodyPr wrap="square" lIns="96012" tIns="96012" rIns="82296" bIns="41148" rtlCol="0" anchor="t"/>
+          <a:lstStyle/>
+          <a:p>
+            <a:pPr algn="l">
+              <a:lnSpc>
+                <a:spcPct val="105000"/>
+              </a:lnSpc>
+              <a:spcAft>
+                <a:spcPts val="225"/>
+              </a:spcAft>
+            </a:pPr>
+            <a:r>
+              <a:rPr sz="1012" b="1">
+                <a:solidFill>
+                  <a:srgbClr val="053238"/>
+                </a:solidFill>
+                <a:latin typeface="Arial"/>
+              </a:rPr>
+              <a:t>A bad supplier</a:t>
+            </a:r>
+          </a:p>
+          <a:p>
+            <a:pPr algn="l">
+              <a:lnSpc>
+                <a:spcPct val="105000"/>
+              </a:lnSpc>
+            </a:pPr>
+            <a:r>
+              <a:rPr sz="825" b="1">
+                <a:solidFill>
+                  <a:srgbClr val="44655F"/>
+                </a:solidFill>
+                <a:latin typeface="Arial"/>
+              </a:rPr>
+              <a:t>Risk: </a:t>
+            </a:r>
+            <a:r>
+              <a:rPr sz="825">
+                <a:solidFill>
+                  <a:srgbClr val="44655F"/>
+                </a:solidFill>
+                <a:latin typeface="Arial"/>
+              </a:rPr>
+              <a:t>one unvetted farm erodes the brand. </a:t>
+            </a:r>
+            <a:r>
+              <a:rPr sz="825" b="1">
+                <a:solidFill>
+                  <a:srgbClr val="44655F"/>
+                </a:solidFill>
+                <a:latin typeface="Arial"/>
+              </a:rPr>
+              <a:t>Fix: </a:t>
+            </a:r>
+            <a:r>
+              <a:rPr sz="825">
+                <a:solidFill>
+                  <a:srgbClr val="44655F"/>
+                </a:solidFill>
+                <a:latin typeface="Arial"/>
+              </a:rPr>
+              <a:t>admin approval before anything is listed; fulfilment failures auto-refund and flag the supplier.</a:t>
+            </a:r>
+          </a:p>
+        </p:txBody>
+      </p:sp>
+      <p:sp>
+        <p:nvSpPr>
+          <p:cNvPr id="9" name="Rectangle 8"/>
+          <p:cNvSpPr/>
+          <p:nvPr/>
+        </p:nvSpPr>
+        <p:spPr>
+          <a:xfrm>
+            <a:off x="6228092" y="2756915"/>
+            <a:ext cx="377190" cy="37719"/>
+          </a:xfrm>
+          <a:prstGeom prst="rect">
+            <a:avLst/>
+          </a:prstGeom>
+          <a:solidFill>
+            <a:srgbClr val="940758"/>
+          </a:solidFill>
+          <a:ln>
+            <a:noFill/>
+          </a:ln>
+          <a:effectLst/>
+        </p:spPr>
+        <p:style>
+          <a:lnRef idx="1">
+            <a:schemeClr val="accent1"/>
+          </a:lnRef>
+          <a:fillRef idx="3">
+            <a:schemeClr val="accent1"/>
+          </a:fillRef>
+          <a:effectRef idx="2">
+            <a:schemeClr val="accent1"/>
+          </a:effectRef>
+          <a:fontRef idx="minor">
+            <a:schemeClr val="lt1"/>
+          </a:fontRef>
+        </p:style>
+        <p:txBody>
+          <a:bodyPr rtlCol="0" anchor="ctr"/>
+          <a:lstStyle/>
+          <a:p>
+            <a:pPr algn="ctr"/>
+            <a:endParaRPr/>
+          </a:p>
+        </p:txBody>
+      </p:sp>
+      <p:sp>
+        <p:nvSpPr>
+          <p:cNvPr id="10" name="Rounded Rectangle 9"/>
+          <p:cNvSpPr/>
+          <p:nvPr/>
+        </p:nvSpPr>
+        <p:spPr>
+          <a:xfrm>
+            <a:off x="302780" y="3106674"/>
+            <a:ext cx="2708910" cy="1357884"/>
+          </a:xfrm>
+          <a:prstGeom prst="roundRect">
+            <a:avLst>
+              <a:gd name="adj" fmla="val 8000"/>
+            </a:avLst>
+          </a:prstGeom>
+          <a:solidFill>
+            <a:srgbClr val="FFFFFF"/>
+          </a:solidFill>
+          <a:ln w="11906">
+            <a:solidFill>
+              <a:srgbClr val="D4E8DC"/>
+            </a:solidFill>
+          </a:ln>
+          <a:effectLst/>
+        </p:spPr>
+        <p:style>
+          <a:lnRef idx="1">
+            <a:schemeClr val="accent1"/>
+          </a:lnRef>
+          <a:fillRef idx="3">
+            <a:schemeClr val="accent1"/>
+          </a:fillRef>
+          <a:effectRef idx="2">
+            <a:schemeClr val="accent1"/>
+          </a:effectRef>
+          <a:fontRef idx="minor">
+            <a:schemeClr val="lt1"/>
+          </a:fontRef>
+        </p:style>
+        <p:txBody>
+          <a:bodyPr wrap="square" lIns="96012" tIns="96012" rIns="82296" bIns="41148" rtlCol="0" anchor="t"/>
+          <a:lstStyle/>
+          <a:p>
+            <a:pPr algn="l">
+              <a:lnSpc>
+                <a:spcPct val="105000"/>
+              </a:lnSpc>
+              <a:spcAft>
+                <a:spcPts val="225"/>
+              </a:spcAft>
+            </a:pPr>
+            <a:r>
+              <a:rPr sz="1012" b="1">
+                <a:solidFill>
+                  <a:srgbClr val="053238"/>
+                </a:solidFill>
+                <a:latin typeface="Arial"/>
+              </a:rPr>
+              <a:t>A one-character bug</a:t>
+            </a:r>
+          </a:p>
+          <a:p>
+            <a:pPr algn="l">
+              <a:lnSpc>
+                <a:spcPct val="105000"/>
+              </a:lnSpc>
+            </a:pPr>
+            <a:r>
+              <a:rPr sz="825" b="1">
+                <a:solidFill>
+                  <a:srgbClr val="44655F"/>
+                </a:solidFill>
+                <a:latin typeface="Arial"/>
+              </a:rPr>
+              <a:t>Risk: </a:t>
+            </a:r>
+            <a:r>
+              <a:rPr sz="825">
+                <a:solidFill>
+                  <a:srgbClr val="44655F"/>
+                </a:solidFill>
+                <a:latin typeface="Arial"/>
+              </a:rPr>
+              <a:t>a single apostrophe once broke the whole app. </a:t>
+            </a:r>
+            <a:r>
+              <a:rPr sz="825" b="1">
+                <a:solidFill>
+                  <a:srgbClr val="44655F"/>
+                </a:solidFill>
+                <a:latin typeface="Arial"/>
+              </a:rPr>
+              <a:t>Fix: </a:t>
+            </a:r>
+            <a:r>
+              <a:rPr sz="825">
+                <a:solidFill>
+                  <a:srgbClr val="44655F"/>
+                </a:solidFill>
+                <a:latin typeface="Arial"/>
+              </a:rPr>
+              <a:t>CI now syntax-checks, runs all 14 tests and smoke-tests the Docker image on every push.</a:t>
+            </a:r>
+          </a:p>
+        </p:txBody>
+      </p:sp>
+      <p:sp>
+        <p:nvSpPr>
+          <p:cNvPr id="11" name="Rectangle 10"/>
+          <p:cNvSpPr/>
+          <p:nvPr/>
+        </p:nvSpPr>
+        <p:spPr>
+          <a:xfrm>
+            <a:off x="398792" y="4354830"/>
+            <a:ext cx="377190" cy="37719"/>
+          </a:xfrm>
+          <a:prstGeom prst="rect">
+            <a:avLst/>
+          </a:prstGeom>
+          <a:solidFill>
+            <a:srgbClr val="940758"/>
+          </a:solidFill>
+          <a:ln>
+            <a:noFill/>
+          </a:ln>
+          <a:effectLst/>
+        </p:spPr>
+        <p:style>
+          <a:lnRef idx="1">
+            <a:schemeClr val="accent1"/>
+          </a:lnRef>
+          <a:fillRef idx="3">
+            <a:schemeClr val="accent1"/>
+          </a:fillRef>
+          <a:effectRef idx="2">
+            <a:schemeClr val="accent1"/>
+          </a:effectRef>
+          <a:fontRef idx="minor">
+            <a:schemeClr val="lt1"/>
+          </a:fontRef>
+        </p:style>
+        <p:txBody>
+          <a:bodyPr rtlCol="0" anchor="ctr"/>
+          <a:lstStyle/>
+          <a:p>
+            <a:pPr algn="ctr"/>
+            <a:endParaRPr/>
+          </a:p>
+        </p:txBody>
+      </p:sp>
+      <p:sp>
+        <p:nvSpPr>
+          <p:cNvPr id="12" name="Rounded Rectangle 11"/>
+          <p:cNvSpPr/>
+          <p:nvPr/>
+        </p:nvSpPr>
+        <p:spPr>
+          <a:xfrm>
+            <a:off x="3217430" y="3106674"/>
+            <a:ext cx="2708910" cy="1357884"/>
+          </a:xfrm>
+          <a:prstGeom prst="roundRect">
+            <a:avLst>
+              <a:gd name="adj" fmla="val 8000"/>
+            </a:avLst>
+          </a:prstGeom>
+          <a:solidFill>
+            <a:srgbClr val="FFFFFF"/>
+          </a:solidFill>
+          <a:ln w="11906">
+            <a:solidFill>
+              <a:srgbClr val="D4E8DC"/>
+            </a:solidFill>
+          </a:ln>
+          <a:effectLst/>
+        </p:spPr>
+        <p:style>
+          <a:lnRef idx="1">
+            <a:schemeClr val="accent1"/>
+          </a:lnRef>
+          <a:fillRef idx="3">
+            <a:schemeClr val="accent1"/>
+          </a:fillRef>
+          <a:effectRef idx="2">
+            <a:schemeClr val="accent1"/>
+          </a:effectRef>
+          <a:fontRef idx="minor">
+            <a:schemeClr val="lt1"/>
+          </a:fontRef>
+        </p:style>
+        <p:txBody>
+          <a:bodyPr wrap="square" lIns="96012" tIns="96012" rIns="82296" bIns="41148" rtlCol="0" anchor="t"/>
+          <a:lstStyle/>
+          <a:p>
+            <a:pPr algn="l">
+              <a:lnSpc>
+                <a:spcPct val="105000"/>
+              </a:lnSpc>
+              <a:spcAft>
+                <a:spcPts val="225"/>
+              </a:spcAft>
+            </a:pPr>
+            <a:r>
+              <a:rPr sz="1012" b="1">
+                <a:solidFill>
+                  <a:srgbClr val="053238"/>
+                </a:solidFill>
+                <a:latin typeface="Arial"/>
+              </a:rPr>
+              <a:t>Chatbot answering wrongly</a:t>
+            </a:r>
+          </a:p>
+          <a:p>
+            <a:pPr algn="l">
+              <a:lnSpc>
+                <a:spcPct val="105000"/>
+              </a:lnSpc>
+            </a:pPr>
+            <a:r>
+              <a:rPr sz="825" b="1">
+                <a:solidFill>
+                  <a:srgbClr val="44655F"/>
+                </a:solidFill>
+                <a:latin typeface="Arial"/>
+              </a:rPr>
+              <a:t>Risk: </a:t>
+            </a:r>
+            <a:r>
+              <a:rPr sz="825">
+                <a:solidFill>
+                  <a:srgbClr val="44655F"/>
+                </a:solidFill>
+                <a:latin typeface="Arial"/>
+              </a:rPr>
+              <a:t>confident wrong answers to customers. </a:t>
+            </a:r>
+            <a:r>
+              <a:rPr sz="825" b="1">
+                <a:solidFill>
+                  <a:srgbClr val="44655F"/>
+                </a:solidFill>
+                <a:latin typeface="Arial"/>
+              </a:rPr>
+              <a:t>Fix: </a:t>
+            </a:r>
+            <a:r>
+              <a:rPr sz="825">
+                <a:solidFill>
+                  <a:srgbClr val="44655F"/>
+                </a:solidFill>
+                <a:latin typeface="Arial"/>
+              </a:rPr>
+              <a:t>read-only order data, a scripted scope, and hand-over to a human after two misses.</a:t>
+            </a:r>
+          </a:p>
+        </p:txBody>
+      </p:sp>
+      <p:sp>
+        <p:nvSpPr>
+          <p:cNvPr id="13" name="Rectangle 12"/>
+          <p:cNvSpPr/>
+          <p:nvPr/>
+        </p:nvSpPr>
+        <p:spPr>
+          <a:xfrm>
+            <a:off x="3313442" y="4354830"/>
+            <a:ext cx="377190" cy="37719"/>
+          </a:xfrm>
+          <a:prstGeom prst="rect">
+            <a:avLst/>
+          </a:prstGeom>
+          <a:solidFill>
+            <a:srgbClr val="940758"/>
+          </a:solidFill>
+          <a:ln>
+            <a:noFill/>
+          </a:ln>
+          <a:effectLst/>
+        </p:spPr>
+        <p:style>
+          <a:lnRef idx="1">
+            <a:schemeClr val="accent1"/>
+          </a:lnRef>
+          <a:fillRef idx="3">
+            <a:schemeClr val="accent1"/>
+          </a:fillRef>
+          <a:effectRef idx="2">
+            <a:schemeClr val="accent1"/>
+          </a:effectRef>
+          <a:fontRef idx="minor">
+            <a:schemeClr val="lt1"/>
+          </a:fontRef>
+        </p:style>
+        <p:txBody>
+          <a:bodyPr rtlCol="0" anchor="ctr"/>
+          <a:lstStyle/>
+          <a:p>
+            <a:pPr algn="ctr"/>
+            <a:endParaRPr/>
+          </a:p>
+        </p:txBody>
+      </p:sp>
+      <p:sp>
+        <p:nvSpPr>
+          <p:cNvPr id="14" name="Rounded Rectangle 13"/>
+          <p:cNvSpPr/>
+          <p:nvPr/>
+        </p:nvSpPr>
+        <p:spPr>
+          <a:xfrm>
+            <a:off x="6132080" y="3106674"/>
+            <a:ext cx="2708910" cy="1357884"/>
+          </a:xfrm>
+          <a:prstGeom prst="roundRect">
+            <a:avLst>
+              <a:gd name="adj" fmla="val 8000"/>
+            </a:avLst>
+          </a:prstGeom>
+          <a:solidFill>
+            <a:srgbClr val="FFFFFF"/>
+          </a:solidFill>
+          <a:ln w="11906">
+            <a:solidFill>
+              <a:srgbClr val="D4E8DC"/>
+            </a:solidFill>
+          </a:ln>
+          <a:effectLst/>
+        </p:spPr>
+        <p:style>
+          <a:lnRef idx="1">
+            <a:schemeClr val="accent1"/>
+          </a:lnRef>
+          <a:fillRef idx="3">
+            <a:schemeClr val="accent1"/>
+          </a:fillRef>
+          <a:effectRef idx="2">
+            <a:schemeClr val="accent1"/>
+          </a:effectRef>
+          <a:fontRef idx="minor">
+            <a:schemeClr val="lt1"/>
+          </a:fontRef>
+        </p:style>
+        <p:txBody>
+          <a:bodyPr wrap="square" lIns="96012" tIns="96012" rIns="82296" bIns="41148" rtlCol="0" anchor="t"/>
+          <a:lstStyle/>
+          <a:p>
+            <a:pPr algn="l">
+              <a:lnSpc>
+                <a:spcPct val="105000"/>
+              </a:lnSpc>
+              <a:spcAft>
+                <a:spcPts val="225"/>
+              </a:spcAft>
+            </a:pPr>
+            <a:r>
+              <a:rPr sz="1012" b="1">
+                <a:solidFill>
+                  <a:srgbClr val="053238"/>
+                </a:solidFill>
+                <a:latin typeface="Arial"/>
+              </a:rPr>
+              <a:t>Prototype-to-production drift</a:t>
+            </a:r>
+          </a:p>
+          <a:p>
+            <a:pPr algn="l">
+              <a:lnSpc>
+                <a:spcPct val="105000"/>
+              </a:lnSpc>
+            </a:pPr>
+            <a:r>
+              <a:rPr sz="825" b="1">
+                <a:solidFill>
+                  <a:srgbClr val="44655F"/>
+                </a:solidFill>
+                <a:latin typeface="Arial"/>
+              </a:rPr>
+              <a:t>Risk: </a:t>
+            </a:r>
+            <a:r>
+              <a:rPr sz="825">
+                <a:solidFill>
+                  <a:srgbClr val="44655F"/>
+                </a:solidFill>
+                <a:latin typeface="Arial"/>
+              </a:rPr>
+              <a:t>production means starting again. </a:t>
+            </a:r>
+            <a:r>
+              <a:rPr sz="825" b="1">
+                <a:solidFill>
+                  <a:srgbClr val="44655F"/>
+                </a:solidFill>
+                <a:latin typeface="Arial"/>
+              </a:rPr>
+              <a:t>Fix: </a:t>
+            </a:r>
+            <a:r>
+              <a:rPr sz="825">
+                <a:solidFill>
+                  <a:srgbClr val="44655F"/>
+                </a:solidFill>
+                <a:latin typeface="Arial"/>
+              </a:rPr>
+              <a:t>the service map is the production architecture — each service becomes an API behind the same seams.</a:t>
+            </a:r>
+          </a:p>
+        </p:txBody>
+      </p:sp>
+      <p:sp>
+        <p:nvSpPr>
+          <p:cNvPr id="15" name="Rectangle 14"/>
+          <p:cNvSpPr/>
+          <p:nvPr/>
+        </p:nvSpPr>
+        <p:spPr>
+          <a:xfrm>
+            <a:off x="6228092" y="4354830"/>
+            <a:ext cx="377190" cy="37719"/>
+          </a:xfrm>
+          <a:prstGeom prst="rect">
+            <a:avLst/>
+          </a:prstGeom>
+          <a:solidFill>
+            <a:srgbClr val="940758"/>
+          </a:solidFill>
+          <a:ln>
+            <a:noFill/>
+          </a:ln>
+          <a:effectLst/>
+        </p:spPr>
+        <p:style>
+          <a:lnRef idx="1">
+            <a:schemeClr val="accent1"/>
+          </a:lnRef>
+          <a:fillRef idx="3">
+            <a:schemeClr val="accent1"/>
+          </a:fillRef>
+          <a:effectRef idx="2">
+            <a:schemeClr val="accent1"/>
+          </a:effectRef>
+          <a:fontRef idx="minor">
+            <a:schemeClr val="lt1"/>
+          </a:fontRef>
+        </p:style>
+        <p:txBody>
+          <a:bodyPr rtlCol="0" anchor="ctr"/>
+          <a:lstStyle/>
+          <a:p>
+            <a:pPr algn="ctr"/>
+            <a:endParaRPr/>
+          </a:p>
+        </p:txBody>
+      </p:sp>
+      <p:sp>
+        <p:nvSpPr>
+          <p:cNvPr id="16" name="TextBox 15"/>
+          <p:cNvSpPr txBox="1"/>
+          <p:nvPr/>
+        </p:nvSpPr>
+        <p:spPr>
+          <a:xfrm>
+            <a:off x="377190" y="4834890"/>
+            <a:ext cx="8366760" cy="240030"/>
+          </a:xfrm>
+          <a:prstGeom prst="rect">
+            <a:avLst/>
+          </a:prstGeom>
+          <a:noFill/>
+        </p:spPr>
+        <p:txBody>
+          <a:bodyPr wrap="none">
+            <a:spAutoFit/>
+          </a:bodyPr>
+          <a:lstStyle/>
+          <a:p>
+            <a:r>
+              <a:rPr sz="750">
+                <a:solidFill>
+                  <a:srgbClr val="44655F"/>
+                </a:solidFill>
+                <a:latin typeface="Arial"/>
+              </a:rPr>
+              <a:t>Shop Well — client pitch  ·  14</a:t>
+            </a:r>
+          </a:p>
+        </p:txBody>
+      </p:sp>
+    </p:spTree>
+  </p:cSld>
+  <p:clrMapOvr>
+    <a:masterClrMapping/>
+  </p:clrMapOvr>
+</p:sld>
+</file>
+
+<file path=ppt/slides/slide2.xml><?xml version="1.0" encoding="utf-8"?>
+<p:sld xmlns:a="http://schemas.openxmlformats.org/drawingml/2006/main" xmlns:r="http://schemas.openxmlformats.org/officeDocument/2006/relationships" xmlns:p="http://schemas.openxmlformats.org/presentationml/2006/main">
+  <p:cSld>
+    <p:spTree>
+      <p:nvGrpSpPr>
+        <p:cNvPr id="1" name=""/>
+        <p:cNvGrpSpPr/>
+        <p:nvPr/>
+      </p:nvGrpSpPr>
+      <p:grpSpPr>
+        <a:xfrm>
+          <a:off x="0" y="0"/>
+          <a:ext cx="0" cy="0"/>
+          <a:chOff x="0" y="0"/>
+          <a:chExt cx="0" cy="0"/>
+        </a:xfrm>
+      </p:grpSpPr>
+      <p:sp>
+        <p:nvSpPr>
+          <p:cNvPr id="2" name="Rectangle 1"/>
+          <p:cNvSpPr/>
+          <p:nvPr/>
+        </p:nvSpPr>
+        <p:spPr>
+          <a:xfrm>
+            <a:off x="0" y="288036"/>
+            <a:ext cx="9143771" cy="5143500"/>
+          </a:xfrm>
+          <a:prstGeom prst="rect">
+            <a:avLst/>
+          </a:prstGeom>
+          <a:solidFill>
+            <a:srgbClr val="F2F8F3"/>
+          </a:solidFill>
+          <a:ln>
+            <a:noFill/>
+          </a:ln>
+          <a:effectLst/>
+        </p:spPr>
+        <p:style>
+          <a:lnRef idx="1">
+            <a:schemeClr val="accent1"/>
+          </a:lnRef>
+          <a:fillRef idx="3">
+            <a:schemeClr val="accent1"/>
+          </a:fillRef>
+          <a:effectRef idx="2">
+            <a:schemeClr val="accent1"/>
+          </a:effectRef>
+          <a:fontRef idx="minor">
+            <a:schemeClr val="lt1"/>
+          </a:fontRef>
+        </p:style>
+        <p:txBody>
+          <a:bodyPr rtlCol="0" anchor="ctr"/>
+          <a:lstStyle/>
+          <a:p>
+            <a:pPr algn="ctr"/>
+            <a:endParaRPr/>
+          </a:p>
+        </p:txBody>
+      </p:sp>
+      <p:sp>
+        <p:nvSpPr>
+          <p:cNvPr id="3" name="TextBox 2"/>
+          <p:cNvSpPr txBox="1"/>
+          <p:nvPr/>
+        </p:nvSpPr>
+        <p:spPr>
+          <a:xfrm>
+            <a:off x="377190" y="288036"/>
+            <a:ext cx="8366760" cy="588366"/>
+          </a:xfrm>
+          <a:prstGeom prst="rect">
+            <a:avLst/>
+          </a:prstGeom>
+          <a:noFill/>
+        </p:spPr>
+        <p:txBody>
+          <a:bodyPr wrap="square" lIns="0" tIns="0" rIns="0" bIns="0" anchor="t">
+            <a:spAutoFit/>
+          </a:bodyPr>
+          <a:lstStyle/>
+          <a:p>
+            <a:pPr algn="l">
+              <a:lnSpc>
+                <a:spcPct val="108000"/>
+              </a:lnSpc>
+              <a:spcAft>
+                <a:spcPts val="450"/>
+              </a:spcAft>
+            </a:pPr>
+            <a:r>
+              <a:rPr sz="938" b="1" dirty="0">
+                <a:solidFill>
+                  <a:srgbClr val="940758"/>
+                </a:solidFill>
+                <a:latin typeface="Arial"/>
+              </a:rPr>
+              <a:t>THE PROBLEM</a:t>
+            </a:r>
+          </a:p>
+          <a:p>
+            <a:pPr algn="l">
+              <a:lnSpc>
+                <a:spcPct val="108000"/>
+              </a:lnSpc>
+              <a:spcAft>
+                <a:spcPts val="300"/>
+              </a:spcAft>
+            </a:pPr>
+            <a:r>
+              <a:rPr sz="2325" b="1" dirty="0">
+                <a:solidFill>
+                  <a:srgbClr val="053238"/>
+                </a:solidFill>
+                <a:latin typeface="Arial Black"/>
+              </a:rPr>
+              <a:t>Organic food is thriving. Buying it isn't.</a:t>
+            </a:r>
+          </a:p>
+        </p:txBody>
+      </p:sp>
+      <p:sp>
+        <p:nvSpPr>
+          <p:cNvPr id="4" name="Rounded Rectangle 3"/>
+          <p:cNvSpPr/>
+          <p:nvPr/>
+        </p:nvSpPr>
+        <p:spPr>
+          <a:xfrm>
+            <a:off x="319925" y="1474470"/>
+            <a:ext cx="2674620" cy="2297430"/>
+          </a:xfrm>
+          <a:prstGeom prst="roundRect">
+            <a:avLst>
+              <a:gd name="adj" fmla="val 8000"/>
+            </a:avLst>
+          </a:prstGeom>
+          <a:solidFill>
+            <a:srgbClr val="FFFFFF"/>
+          </a:solidFill>
+          <a:ln w="11906">
+            <a:solidFill>
+              <a:srgbClr val="D4E8DC"/>
+            </a:solidFill>
+          </a:ln>
+          <a:effectLst/>
+        </p:spPr>
+        <p:style>
+          <a:lnRef idx="1">
+            <a:schemeClr val="accent1"/>
+          </a:lnRef>
+          <a:fillRef idx="3">
+            <a:schemeClr val="accent1"/>
+          </a:fillRef>
+          <a:effectRef idx="2">
+            <a:schemeClr val="accent1"/>
+          </a:effectRef>
+          <a:fontRef idx="minor">
+            <a:schemeClr val="lt1"/>
+          </a:fontRef>
+        </p:style>
+        <p:txBody>
+          <a:bodyPr wrap="square" lIns="96012" tIns="96012" rIns="82296" bIns="41148" rtlCol="0" anchor="t"/>
+          <a:lstStyle/>
+          <a:p>
+            <a:pPr algn="l">
+              <a:lnSpc>
+                <a:spcPct val="105000"/>
+              </a:lnSpc>
+              <a:spcAft>
+                <a:spcPts val="225"/>
+              </a:spcAft>
+            </a:pPr>
+            <a:r>
+              <a:rPr sz="1162" b="1" dirty="0">
+                <a:solidFill>
+                  <a:srgbClr val="053238"/>
+                </a:solidFill>
+                <a:latin typeface="Arial"/>
+              </a:rPr>
+              <a:t>Customers want traceability</a:t>
+            </a:r>
+          </a:p>
+          <a:p>
+            <a:pPr algn="l">
+              <a:lnSpc>
+                <a:spcPct val="105000"/>
+              </a:lnSpc>
+            </a:pPr>
+            <a:r>
+              <a:rPr sz="900" dirty="0">
+                <a:solidFill>
+                  <a:srgbClr val="44655F"/>
+                </a:solidFill>
+                <a:latin typeface="Arial"/>
+              </a:rPr>
+              <a:t>Shoppers want organic produce and want to know exactly which farm it came from. Today that means juggling separate farm shops, separate baskets, separate deliveries and separate payments for every single one.</a:t>
+            </a:r>
+          </a:p>
+        </p:txBody>
+      </p:sp>
+      <p:sp>
+        <p:nvSpPr>
+          <p:cNvPr id="5" name="Rectangle 4"/>
+          <p:cNvSpPr/>
+          <p:nvPr/>
+        </p:nvSpPr>
+        <p:spPr>
+          <a:xfrm>
+            <a:off x="415937" y="3662172"/>
+            <a:ext cx="377190" cy="37719"/>
+          </a:xfrm>
+          <a:prstGeom prst="rect">
+            <a:avLst/>
+          </a:prstGeom>
+          <a:solidFill>
+            <a:srgbClr val="940758"/>
+          </a:solidFill>
+          <a:ln>
+            <a:noFill/>
+          </a:ln>
+          <a:effectLst/>
+        </p:spPr>
+        <p:style>
+          <a:lnRef idx="1">
+            <a:schemeClr val="accent1"/>
+          </a:lnRef>
+          <a:fillRef idx="3">
+            <a:schemeClr val="accent1"/>
+          </a:fillRef>
+          <a:effectRef idx="2">
+            <a:schemeClr val="accent1"/>
+          </a:effectRef>
+          <a:fontRef idx="minor">
+            <a:schemeClr val="lt1"/>
+          </a:fontRef>
+        </p:style>
+        <p:txBody>
+          <a:bodyPr rtlCol="0" anchor="ctr"/>
+          <a:lstStyle/>
+          <a:p>
+            <a:pPr algn="ctr"/>
+            <a:endParaRPr/>
+          </a:p>
+        </p:txBody>
+      </p:sp>
+      <p:sp>
+        <p:nvSpPr>
+          <p:cNvPr id="6" name="Rounded Rectangle 5"/>
+          <p:cNvSpPr/>
+          <p:nvPr/>
+        </p:nvSpPr>
+        <p:spPr>
+          <a:xfrm>
+            <a:off x="3234575" y="1474470"/>
+            <a:ext cx="2674620" cy="2297430"/>
+          </a:xfrm>
+          <a:prstGeom prst="roundRect">
+            <a:avLst>
+              <a:gd name="adj" fmla="val 8000"/>
+            </a:avLst>
+          </a:prstGeom>
+          <a:solidFill>
+            <a:srgbClr val="FFFFFF"/>
+          </a:solidFill>
+          <a:ln w="11906">
+            <a:solidFill>
+              <a:srgbClr val="D4E8DC"/>
+            </a:solidFill>
+          </a:ln>
+          <a:effectLst/>
+        </p:spPr>
+        <p:style>
+          <a:lnRef idx="1">
+            <a:schemeClr val="accent1"/>
+          </a:lnRef>
+          <a:fillRef idx="3">
+            <a:schemeClr val="accent1"/>
+          </a:fillRef>
+          <a:effectRef idx="2">
+            <a:schemeClr val="accent1"/>
+          </a:effectRef>
+          <a:fontRef idx="minor">
+            <a:schemeClr val="lt1"/>
+          </a:fontRef>
+        </p:style>
+        <p:txBody>
+          <a:bodyPr wrap="square" lIns="96012" tIns="96012" rIns="82296" bIns="41148" rtlCol="0" anchor="t"/>
+          <a:lstStyle/>
+          <a:p>
+            <a:pPr algn="l">
+              <a:lnSpc>
+                <a:spcPct val="105000"/>
+              </a:lnSpc>
+              <a:spcAft>
+                <a:spcPts val="225"/>
+              </a:spcAft>
+            </a:pPr>
+            <a:r>
+              <a:rPr sz="1162" b="1">
+                <a:solidFill>
+                  <a:srgbClr val="053238"/>
+                </a:solidFill>
+                <a:latin typeface="Arial"/>
+              </a:rPr>
+              <a:t>Small suppliers lack reach</a:t>
+            </a:r>
+          </a:p>
+          <a:p>
+            <a:pPr algn="l">
+              <a:lnSpc>
+                <a:spcPct val="105000"/>
+              </a:lnSpc>
+            </a:pPr>
+            <a:r>
+              <a:rPr sz="900">
+                <a:solidFill>
+                  <a:srgbClr val="44655F"/>
+                </a:solidFill>
+                <a:latin typeface="Arial"/>
+              </a:rPr>
+              <a:t>Independent organic farms rarely have the time or budget for their own online store. On big marketplaces they get buried, lose their identity, and give up control of pricing and stock.</a:t>
+            </a:r>
+          </a:p>
+        </p:txBody>
+      </p:sp>
+      <p:sp>
+        <p:nvSpPr>
+          <p:cNvPr id="7" name="Rectangle 6"/>
+          <p:cNvSpPr/>
+          <p:nvPr/>
+        </p:nvSpPr>
+        <p:spPr>
+          <a:xfrm>
+            <a:off x="3330587" y="3662172"/>
+            <a:ext cx="377190" cy="37719"/>
+          </a:xfrm>
+          <a:prstGeom prst="rect">
+            <a:avLst/>
+          </a:prstGeom>
+          <a:solidFill>
+            <a:srgbClr val="940758"/>
+          </a:solidFill>
+          <a:ln>
+            <a:noFill/>
+          </a:ln>
+          <a:effectLst/>
+        </p:spPr>
+        <p:style>
+          <a:lnRef idx="1">
+            <a:schemeClr val="accent1"/>
+          </a:lnRef>
+          <a:fillRef idx="3">
+            <a:schemeClr val="accent1"/>
+          </a:fillRef>
+          <a:effectRef idx="2">
+            <a:schemeClr val="accent1"/>
+          </a:effectRef>
+          <a:fontRef idx="minor">
+            <a:schemeClr val="lt1"/>
+          </a:fontRef>
+        </p:style>
+        <p:txBody>
+          <a:bodyPr rtlCol="0" anchor="ctr"/>
+          <a:lstStyle/>
+          <a:p>
+            <a:pPr algn="ctr"/>
+            <a:endParaRPr/>
+          </a:p>
+        </p:txBody>
+      </p:sp>
+      <p:sp>
+        <p:nvSpPr>
+          <p:cNvPr id="8" name="Rounded Rectangle 7"/>
+          <p:cNvSpPr/>
+          <p:nvPr/>
+        </p:nvSpPr>
+        <p:spPr>
+          <a:xfrm>
+            <a:off x="6149225" y="1474470"/>
+            <a:ext cx="2674620" cy="2297430"/>
+          </a:xfrm>
+          <a:prstGeom prst="roundRect">
+            <a:avLst>
+              <a:gd name="adj" fmla="val 8000"/>
+            </a:avLst>
+          </a:prstGeom>
+          <a:solidFill>
+            <a:srgbClr val="FFFFFF"/>
+          </a:solidFill>
+          <a:ln w="11906">
+            <a:solidFill>
+              <a:srgbClr val="D4E8DC"/>
+            </a:solidFill>
+          </a:ln>
+          <a:effectLst/>
+        </p:spPr>
+        <p:style>
+          <a:lnRef idx="1">
+            <a:schemeClr val="accent1"/>
+          </a:lnRef>
+          <a:fillRef idx="3">
+            <a:schemeClr val="accent1"/>
+          </a:fillRef>
+          <a:effectRef idx="2">
+            <a:schemeClr val="accent1"/>
+          </a:effectRef>
+          <a:fontRef idx="minor">
+            <a:schemeClr val="lt1"/>
+          </a:fontRef>
+        </p:style>
+        <p:txBody>
+          <a:bodyPr wrap="square" lIns="96012" tIns="96012" rIns="82296" bIns="41148" rtlCol="0" anchor="t"/>
+          <a:lstStyle/>
+          <a:p>
+            <a:pPr algn="l">
+              <a:lnSpc>
+                <a:spcPct val="105000"/>
+              </a:lnSpc>
+              <a:spcAft>
+                <a:spcPts val="225"/>
+              </a:spcAft>
+            </a:pPr>
+            <a:r>
+              <a:rPr sz="1162" b="1" dirty="0">
+                <a:solidFill>
+                  <a:srgbClr val="053238"/>
+                </a:solidFill>
+                <a:latin typeface="Arial"/>
+              </a:rPr>
+              <a:t>Nobody joins the two</a:t>
+            </a:r>
+          </a:p>
+          <a:p>
+            <a:pPr algn="l">
+              <a:lnSpc>
+                <a:spcPct val="105000"/>
+              </a:lnSpc>
+            </a:pPr>
+            <a:r>
+              <a:rPr sz="900" dirty="0">
+                <a:solidFill>
+                  <a:srgbClr val="44655F"/>
+                </a:solidFill>
+                <a:latin typeface="Arial"/>
+              </a:rPr>
+              <a:t>There is no UK marketplace where one basket can span many vetted organic farms with a single checkout while each farm still ships its own produce and keeps its own brand front and </a:t>
+            </a:r>
+            <a:r>
+              <a:rPr sz="900" dirty="0" err="1">
+                <a:solidFill>
+                  <a:srgbClr val="44655F"/>
+                </a:solidFill>
+                <a:latin typeface="Arial"/>
+              </a:rPr>
+              <a:t>centre</a:t>
+            </a:r>
+            <a:r>
+              <a:rPr sz="900" dirty="0">
+                <a:solidFill>
+                  <a:srgbClr val="44655F"/>
+                </a:solidFill>
+                <a:latin typeface="Arial"/>
+              </a:rPr>
+              <a:t>.</a:t>
+            </a:r>
+          </a:p>
+        </p:txBody>
+      </p:sp>
+      <p:sp>
+        <p:nvSpPr>
+          <p:cNvPr id="9" name="Rectangle 8"/>
+          <p:cNvSpPr/>
+          <p:nvPr/>
+        </p:nvSpPr>
+        <p:spPr>
+          <a:xfrm>
+            <a:off x="6245237" y="3662172"/>
+            <a:ext cx="377190" cy="37719"/>
+          </a:xfrm>
+          <a:prstGeom prst="rect">
+            <a:avLst/>
+          </a:prstGeom>
+          <a:solidFill>
+            <a:srgbClr val="940758"/>
+          </a:solidFill>
+          <a:ln>
+            <a:noFill/>
+          </a:ln>
+          <a:effectLst/>
+        </p:spPr>
+        <p:style>
+          <a:lnRef idx="1">
+            <a:schemeClr val="accent1"/>
+          </a:lnRef>
+          <a:fillRef idx="3">
+            <a:schemeClr val="accent1"/>
+          </a:fillRef>
+          <a:effectRef idx="2">
+            <a:schemeClr val="accent1"/>
+          </a:effectRef>
+          <a:fontRef idx="minor">
+            <a:schemeClr val="lt1"/>
+          </a:fontRef>
+        </p:style>
+        <p:txBody>
+          <a:bodyPr rtlCol="0" anchor="ctr"/>
+          <a:lstStyle/>
+          <a:p>
+            <a:pPr algn="ctr"/>
+            <a:endParaRPr/>
+          </a:p>
+        </p:txBody>
+      </p:sp>
+      <p:sp>
+        <p:nvSpPr>
+          <p:cNvPr id="10" name="Rounded Rectangle 9"/>
+          <p:cNvSpPr/>
+          <p:nvPr/>
+        </p:nvSpPr>
+        <p:spPr>
+          <a:xfrm>
+            <a:off x="2311146" y="4080510"/>
+            <a:ext cx="4526280" cy="342900"/>
+          </a:xfrm>
+          <a:prstGeom prst="roundRect">
+            <a:avLst>
+              <a:gd name="adj" fmla="val 50000"/>
+            </a:avLst>
+          </a:prstGeom>
+          <a:solidFill>
+            <a:srgbClr val="940758"/>
+          </a:solidFill>
+          <a:ln>
+            <a:noFill/>
+          </a:ln>
+          <a:effectLst/>
+        </p:spPr>
+        <p:style>
+          <a:lnRef idx="1">
+            <a:schemeClr val="accent1"/>
+          </a:lnRef>
+          <a:fillRef idx="3">
+            <a:schemeClr val="accent1"/>
+          </a:fillRef>
+          <a:effectRef idx="2">
+            <a:schemeClr val="accent1"/>
+          </a:effectRef>
+          <a:fontRef idx="minor">
+            <a:schemeClr val="lt1"/>
+          </a:fontRef>
+        </p:style>
+        <p:txBody>
+          <a:bodyPr wrap="square" lIns="82296" tIns="0" rIns="82296" bIns="0" rtlCol="0" anchor="ctr"/>
+          <a:lstStyle/>
+          <a:p>
+            <a:pPr algn="ctr"/>
+            <a:r>
+              <a:rPr sz="975" b="1" dirty="0">
+                <a:solidFill>
+                  <a:srgbClr val="FFFFFF"/>
+                </a:solidFill>
+                <a:latin typeface="Arial"/>
+              </a:rPr>
+              <a:t>The gap in the market is the connection </a:t>
+            </a:r>
+            <a:r>
+              <a:rPr lang="en-GB" sz="975" b="1" dirty="0">
+                <a:solidFill>
+                  <a:srgbClr val="FFFFFF"/>
+                </a:solidFill>
+                <a:latin typeface="Arial"/>
+              </a:rPr>
+              <a:t>-</a:t>
+            </a:r>
+            <a:r>
+              <a:rPr sz="975" b="1" dirty="0">
+                <a:solidFill>
+                  <a:srgbClr val="FFFFFF"/>
+                </a:solidFill>
+                <a:latin typeface="Arial"/>
+              </a:rPr>
+              <a:t> that's Shop Well.</a:t>
+            </a:r>
+          </a:p>
+        </p:txBody>
+      </p:sp>
+      <p:sp>
+        <p:nvSpPr>
+          <p:cNvPr id="11" name="TextBox 10"/>
+          <p:cNvSpPr txBox="1"/>
+          <p:nvPr/>
+        </p:nvSpPr>
+        <p:spPr>
+          <a:xfrm>
+            <a:off x="377190" y="4834890"/>
+            <a:ext cx="814647" cy="207749"/>
+          </a:xfrm>
+          <a:prstGeom prst="rect">
+            <a:avLst/>
+          </a:prstGeom>
+          <a:noFill/>
+        </p:spPr>
+        <p:txBody>
+          <a:bodyPr wrap="none">
+            <a:spAutoFit/>
+          </a:bodyPr>
+          <a:lstStyle/>
+          <a:p>
+            <a:r>
+              <a:rPr sz="750" dirty="0">
+                <a:solidFill>
+                  <a:srgbClr val="44655F"/>
+                </a:solidFill>
+                <a:latin typeface="Arial"/>
+              </a:rPr>
+              <a:t>Shop Well  ·  2</a:t>
             </a:r>
           </a:p>
         </p:txBody>
@@ -13091,7 +15392,7 @@
 </file>
 
 <file path=ppt/slides/slide3.xml><?xml version="1.0" encoding="utf-8"?>
-<p:sld xmlns:a="http://schemas.openxmlformats.org/drawingml/2006/main" xmlns:p="http://schemas.openxmlformats.org/presentationml/2006/main" xmlns:r="http://schemas.openxmlformats.org/officeDocument/2006/relationships">
+<p:sld xmlns:a="http://schemas.openxmlformats.org/drawingml/2006/main" xmlns:r="http://schemas.openxmlformats.org/officeDocument/2006/relationships" xmlns:p="http://schemas.openxmlformats.org/presentationml/2006/main">
   <p:cSld>
     <p:spTree>
       <p:nvGrpSpPr>
@@ -13099,7 +15400,14 @@
         <p:cNvGrpSpPr/>
         <p:nvPr/>
       </p:nvGrpSpPr>
-      <p:grpSpPr/>
+      <p:grpSpPr>
+        <a:xfrm>
+          <a:off x="0" y="0"/>
+          <a:ext cx="0" cy="0"/>
+          <a:chOff x="0" y="0"/>
+          <a:chExt cx="0" cy="0"/>
+        </a:xfrm>
+      </p:grpSpPr>
       <p:sp>
         <p:nvSpPr>
           <p:cNvPr id="2" name="Rectangle 1"/>
@@ -13141,6 +15449,7 @@
           <a:lstStyle/>
           <a:p>
             <a:pPr algn="ctr"/>
+            <a:endParaRPr/>
           </a:p>
         </p:txBody>
       </p:sp>
@@ -13161,7 +15470,7 @@
           <a:noFill/>
         </p:spPr>
         <p:txBody>
-          <a:bodyPr wrap="square" anchor="t" lIns="0" rIns="0" tIns="0" bIns="0">
+          <a:bodyPr wrap="square" lIns="0" tIns="0" rIns="0" bIns="0" anchor="t">
             <a:spAutoFit/>
           </a:bodyPr>
           <a:lstStyle/>
@@ -13265,7 +15574,7 @@
           </a:fontRef>
         </p:style>
         <p:txBody>
-          <a:bodyPr rtlCol="0" anchor="t" wrap="square" lIns="96012" rIns="82296" tIns="96012" bIns="41148"/>
+          <a:bodyPr wrap="square" lIns="96012" tIns="96012" rIns="82296" bIns="41148" rtlCol="0" anchor="t"/>
           <a:lstStyle/>
           <a:p>
             <a:pPr algn="l">
@@ -13345,6 +15654,7 @@
           <a:lstStyle/>
           <a:p>
             <a:pPr algn="ctr"/>
+            <a:endParaRPr/>
           </a:p>
         </p:txBody>
       </p:sp>
@@ -13389,7 +15699,7 @@
           </a:fontRef>
         </p:style>
         <p:txBody>
-          <a:bodyPr rtlCol="0" anchor="t" wrap="square" lIns="96012" rIns="82296" tIns="96012" bIns="41148"/>
+          <a:bodyPr wrap="square" lIns="96012" tIns="96012" rIns="82296" bIns="41148" rtlCol="0" anchor="t"/>
           <a:lstStyle/>
           <a:p>
             <a:pPr algn="l">
@@ -13469,6 +15779,7 @@
           <a:lstStyle/>
           <a:p>
             <a:pPr algn="ctr"/>
+            <a:endParaRPr/>
           </a:p>
         </p:txBody>
       </p:sp>
@@ -13513,7 +15824,7 @@
           </a:fontRef>
         </p:style>
         <p:txBody>
-          <a:bodyPr rtlCol="0" anchor="t" wrap="square" lIns="96012" rIns="82296" tIns="96012" bIns="41148"/>
+          <a:bodyPr wrap="square" lIns="96012" tIns="96012" rIns="82296" bIns="41148" rtlCol="0" anchor="t"/>
           <a:lstStyle/>
           <a:p>
             <a:pPr algn="l">
@@ -13593,6 +15904,7 @@
           <a:lstStyle/>
           <a:p>
             <a:pPr algn="ctr"/>
+            <a:endParaRPr/>
           </a:p>
         </p:txBody>
       </p:sp>
@@ -13637,7 +15949,7 @@
           </a:fontRef>
         </p:style>
         <p:txBody>
-          <a:bodyPr rtlCol="0" anchor="t" wrap="square" lIns="96012" rIns="82296" tIns="96012" bIns="41148"/>
+          <a:bodyPr wrap="square" lIns="96012" tIns="96012" rIns="82296" bIns="41148" rtlCol="0" anchor="t"/>
           <a:lstStyle/>
           <a:p>
             <a:pPr algn="l">
@@ -13717,6 +16029,7 @@
           <a:lstStyle/>
           <a:p>
             <a:pPr algn="ctr"/>
+            <a:endParaRPr/>
           </a:p>
         </p:txBody>
       </p:sp>
@@ -13763,7 +16076,7 @@
 </file>
 
 <file path=ppt/slides/slide4.xml><?xml version="1.0" encoding="utf-8"?>
-<p:sld xmlns:a="http://schemas.openxmlformats.org/drawingml/2006/main" xmlns:p="http://schemas.openxmlformats.org/presentationml/2006/main" xmlns:r="http://schemas.openxmlformats.org/officeDocument/2006/relationships">
+<p:sld xmlns:a="http://schemas.openxmlformats.org/drawingml/2006/main" xmlns:r="http://schemas.openxmlformats.org/officeDocument/2006/relationships" xmlns:p="http://schemas.openxmlformats.org/presentationml/2006/main">
   <p:cSld>
     <p:spTree>
       <p:nvGrpSpPr>
@@ -13771,7 +16084,14 @@
         <p:cNvGrpSpPr/>
         <p:nvPr/>
       </p:nvGrpSpPr>
-      <p:grpSpPr/>
+      <p:grpSpPr>
+        <a:xfrm>
+          <a:off x="0" y="0"/>
+          <a:ext cx="0" cy="0"/>
+          <a:chOff x="0" y="0"/>
+          <a:chExt cx="0" cy="0"/>
+        </a:xfrm>
+      </p:grpSpPr>
       <p:sp>
         <p:nvSpPr>
           <p:cNvPr id="2" name="Rectangle 1"/>
@@ -13813,6 +16133,7 @@
           <a:lstStyle/>
           <a:p>
             <a:pPr algn="ctr"/>
+            <a:endParaRPr/>
           </a:p>
         </p:txBody>
       </p:sp>
@@ -13833,7 +16154,7 @@
           <a:noFill/>
         </p:spPr>
         <p:txBody>
-          <a:bodyPr wrap="square" anchor="t" lIns="0" rIns="0" tIns="0" bIns="0">
+          <a:bodyPr wrap="square" lIns="0" tIns="0" rIns="0" bIns="0" anchor="t">
             <a:spAutoFit/>
           </a:bodyPr>
           <a:lstStyle/>
@@ -13937,7 +16258,7 @@
           </a:fontRef>
         </p:style>
         <p:txBody>
-          <a:bodyPr rtlCol="0" anchor="t" wrap="square" lIns="96012" rIns="82296" tIns="96012" bIns="41148"/>
+          <a:bodyPr wrap="square" lIns="96012" tIns="96012" rIns="82296" bIns="41148" rtlCol="0" anchor="t"/>
           <a:lstStyle/>
           <a:p>
             <a:pPr algn="l">
@@ -14017,6 +16338,7 @@
           <a:lstStyle/>
           <a:p>
             <a:pPr algn="ctr"/>
+            <a:endParaRPr/>
           </a:p>
         </p:txBody>
       </p:sp>
@@ -14061,7 +16383,7 @@
           </a:fontRef>
         </p:style>
         <p:txBody>
-          <a:bodyPr rtlCol="0" anchor="t" wrap="square" lIns="96012" rIns="82296" tIns="96012" bIns="41148"/>
+          <a:bodyPr wrap="square" lIns="96012" tIns="96012" rIns="82296" bIns="41148" rtlCol="0" anchor="t"/>
           <a:lstStyle/>
           <a:p>
             <a:pPr algn="l">
@@ -14141,6 +16463,7 @@
           <a:lstStyle/>
           <a:p>
             <a:pPr algn="ctr"/>
+            <a:endParaRPr/>
           </a:p>
         </p:txBody>
       </p:sp>
@@ -14185,7 +16508,7 @@
           </a:fontRef>
         </p:style>
         <p:txBody>
-          <a:bodyPr rtlCol="0" anchor="t" wrap="square" lIns="96012" rIns="82296" tIns="96012" bIns="41148"/>
+          <a:bodyPr wrap="square" lIns="96012" tIns="96012" rIns="82296" bIns="41148" rtlCol="0" anchor="t"/>
           <a:lstStyle/>
           <a:p>
             <a:pPr algn="l">
@@ -14265,6 +16588,7 @@
           <a:lstStyle/>
           <a:p>
             <a:pPr algn="ctr"/>
+            <a:endParaRPr/>
           </a:p>
         </p:txBody>
       </p:sp>
@@ -14309,7 +16633,7 @@
           </a:fontRef>
         </p:style>
         <p:txBody>
-          <a:bodyPr rtlCol="0" anchor="t" wrap="square" lIns="96012" rIns="82296" tIns="96012" bIns="41148"/>
+          <a:bodyPr wrap="square" lIns="96012" tIns="96012" rIns="82296" bIns="41148" rtlCol="0" anchor="t"/>
           <a:lstStyle/>
           <a:p>
             <a:pPr algn="l">
@@ -14389,6 +16713,7 @@
           <a:lstStyle/>
           <a:p>
             <a:pPr algn="ctr"/>
+            <a:endParaRPr/>
           </a:p>
         </p:txBody>
       </p:sp>
@@ -14433,7 +16758,7 @@
           </a:fontRef>
         </p:style>
         <p:txBody>
-          <a:bodyPr rtlCol="0" anchor="t" wrap="square" lIns="96012" rIns="82296" tIns="96012" bIns="41148"/>
+          <a:bodyPr wrap="square" lIns="96012" tIns="96012" rIns="82296" bIns="41148" rtlCol="0" anchor="t"/>
           <a:lstStyle/>
           <a:p>
             <a:pPr algn="l">
@@ -14513,6 +16838,7 @@
           <a:lstStyle/>
           <a:p>
             <a:pPr algn="ctr"/>
+            <a:endParaRPr/>
           </a:p>
         </p:txBody>
       </p:sp>
@@ -14557,7 +16883,7 @@
           </a:fontRef>
         </p:style>
         <p:txBody>
-          <a:bodyPr rtlCol="0" anchor="t" wrap="square" lIns="96012" rIns="82296" tIns="96012" bIns="41148"/>
+          <a:bodyPr wrap="square" lIns="96012" tIns="96012" rIns="82296" bIns="41148" rtlCol="0" anchor="t"/>
           <a:lstStyle/>
           <a:p>
             <a:pPr algn="l">
@@ -14637,6 +16963,7 @@
           <a:lstStyle/>
           <a:p>
             <a:pPr algn="ctr"/>
+            <a:endParaRPr/>
           </a:p>
         </p:txBody>
       </p:sp>
@@ -14679,7 +17006,7 @@
           </a:fontRef>
         </p:style>
         <p:txBody>
-          <a:bodyPr rtlCol="0" anchor="ctr" wrap="square" lIns="82296" rIns="82296" tIns="0" bIns="0"/>
+          <a:bodyPr wrap="square" lIns="82296" tIns="0" rIns="82296" bIns="0" rtlCol="0" anchor="ctr"/>
           <a:lstStyle/>
           <a:p>
             <a:pPr algn="ctr"/>
@@ -14738,7 +17065,7 @@
 </file>
 
 <file path=ppt/slides/slide5.xml><?xml version="1.0" encoding="utf-8"?>
-<p:sld xmlns:a="http://schemas.openxmlformats.org/drawingml/2006/main" xmlns:p="http://schemas.openxmlformats.org/presentationml/2006/main" xmlns:r="http://schemas.openxmlformats.org/officeDocument/2006/relationships">
+<p:sld xmlns:a="http://schemas.openxmlformats.org/drawingml/2006/main" xmlns:r="http://schemas.openxmlformats.org/officeDocument/2006/relationships" xmlns:p="http://schemas.openxmlformats.org/presentationml/2006/main">
   <p:cSld>
     <p:spTree>
       <p:nvGrpSpPr>
@@ -14746,7 +17073,14 @@
         <p:cNvGrpSpPr/>
         <p:nvPr/>
       </p:nvGrpSpPr>
-      <p:grpSpPr/>
+      <p:grpSpPr>
+        <a:xfrm>
+          <a:off x="0" y="0"/>
+          <a:ext cx="0" cy="0"/>
+          <a:chOff x="0" y="0"/>
+          <a:chExt cx="0" cy="0"/>
+        </a:xfrm>
+      </p:grpSpPr>
       <p:sp>
         <p:nvSpPr>
           <p:cNvPr id="2" name="Rectangle 1"/>
@@ -14788,6 +17122,7 @@
           <a:lstStyle/>
           <a:p>
             <a:pPr algn="ctr"/>
+            <a:endParaRPr/>
           </a:p>
         </p:txBody>
       </p:sp>
@@ -14808,7 +17143,7 @@
           <a:noFill/>
         </p:spPr>
         <p:txBody>
-          <a:bodyPr wrap="square" anchor="t" lIns="0" rIns="0" tIns="0" bIns="0">
+          <a:bodyPr wrap="square" lIns="0" tIns="0" rIns="0" bIns="0" anchor="t">
             <a:spAutoFit/>
           </a:bodyPr>
           <a:lstStyle/>
@@ -14893,7 +17228,7 @@
           </a:fontRef>
         </p:style>
         <p:txBody>
-          <a:bodyPr rtlCol="0" anchor="ctr" wrap="square" lIns="96012" rIns="82296" tIns="41148" bIns="41148"/>
+          <a:bodyPr wrap="square" lIns="96012" tIns="41148" rIns="82296" bIns="41148" rtlCol="0" anchor="ctr"/>
           <a:lstStyle/>
           <a:p>
             <a:pPr algn="l">
@@ -14969,7 +17304,7 @@
           </a:fontRef>
         </p:style>
         <p:txBody>
-          <a:bodyPr rtlCol="0" anchor="ctr" wrap="none" lIns="0" rIns="0" tIns="0" bIns="0"/>
+          <a:bodyPr wrap="none" lIns="0" tIns="0" rIns="0" bIns="0" rtlCol="0" anchor="ctr"/>
           <a:lstStyle/>
           <a:p>
             <a:pPr algn="ctr"/>
@@ -15026,7 +17361,7 @@
           </a:fontRef>
         </p:style>
         <p:txBody>
-          <a:bodyPr rtlCol="0" anchor="ctr" wrap="square" lIns="96012" rIns="82296" tIns="41148" bIns="41148"/>
+          <a:bodyPr wrap="square" lIns="96012" tIns="41148" rIns="82296" bIns="41148" rtlCol="0" anchor="ctr"/>
           <a:lstStyle/>
           <a:p>
             <a:pPr algn="l">
@@ -15102,7 +17437,7 @@
           </a:fontRef>
         </p:style>
         <p:txBody>
-          <a:bodyPr rtlCol="0" anchor="ctr" wrap="none" lIns="0" rIns="0" tIns="0" bIns="0"/>
+          <a:bodyPr wrap="none" lIns="0" tIns="0" rIns="0" bIns="0" rtlCol="0" anchor="ctr"/>
           <a:lstStyle/>
           <a:p>
             <a:pPr algn="ctr"/>
@@ -15159,7 +17494,7 @@
           </a:fontRef>
         </p:style>
         <p:txBody>
-          <a:bodyPr rtlCol="0" anchor="ctr" wrap="square" lIns="96012" rIns="82296" tIns="41148" bIns="41148"/>
+          <a:bodyPr wrap="square" lIns="96012" tIns="41148" rIns="82296" bIns="41148" rtlCol="0" anchor="ctr"/>
           <a:lstStyle/>
           <a:p>
             <a:pPr algn="l">
@@ -15235,7 +17570,7 @@
           </a:fontRef>
         </p:style>
         <p:txBody>
-          <a:bodyPr rtlCol="0" anchor="ctr" wrap="none" lIns="0" rIns="0" tIns="0" bIns="0"/>
+          <a:bodyPr wrap="none" lIns="0" tIns="0" rIns="0" bIns="0" rtlCol="0" anchor="ctr"/>
           <a:lstStyle/>
           <a:p>
             <a:pPr algn="ctr"/>
@@ -15292,7 +17627,7 @@
           </a:fontRef>
         </p:style>
         <p:txBody>
-          <a:bodyPr rtlCol="0" anchor="ctr" wrap="square" lIns="96012" rIns="82296" tIns="41148" bIns="41148"/>
+          <a:bodyPr wrap="square" lIns="96012" tIns="41148" rIns="82296" bIns="41148" rtlCol="0" anchor="ctr"/>
           <a:lstStyle/>
           <a:p>
             <a:pPr algn="l">
@@ -15368,7 +17703,7 @@
           </a:fontRef>
         </p:style>
         <p:txBody>
-          <a:bodyPr rtlCol="0" anchor="ctr" wrap="none" lIns="0" rIns="0" tIns="0" bIns="0"/>
+          <a:bodyPr wrap="none" lIns="0" tIns="0" rIns="0" bIns="0" rtlCol="0" anchor="ctr"/>
           <a:lstStyle/>
           <a:p>
             <a:pPr algn="ctr"/>
@@ -15425,7 +17760,7 @@
           </a:fontRef>
         </p:style>
         <p:txBody>
-          <a:bodyPr rtlCol="0" anchor="ctr" wrap="square" lIns="96012" rIns="82296" tIns="41148" bIns="41148"/>
+          <a:bodyPr wrap="square" lIns="96012" tIns="41148" rIns="82296" bIns="41148" rtlCol="0" anchor="ctr"/>
           <a:lstStyle/>
           <a:p>
             <a:pPr algn="l">
@@ -15501,7 +17836,7 @@
           </a:fontRef>
         </p:style>
         <p:txBody>
-          <a:bodyPr rtlCol="0" anchor="ctr" wrap="none" lIns="0" rIns="0" tIns="0" bIns="0"/>
+          <a:bodyPr wrap="none" lIns="0" tIns="0" rIns="0" bIns="0" rtlCol="0" anchor="ctr"/>
           <a:lstStyle/>
           <a:p>
             <a:pPr algn="ctr"/>
@@ -15558,7 +17893,7 @@
           </a:fontRef>
         </p:style>
         <p:txBody>
-          <a:bodyPr rtlCol="0" anchor="ctr" wrap="square" lIns="96012" rIns="82296" tIns="41148" bIns="41148"/>
+          <a:bodyPr wrap="square" lIns="96012" tIns="41148" rIns="82296" bIns="41148" rtlCol="0" anchor="ctr"/>
           <a:lstStyle/>
           <a:p>
             <a:pPr algn="l">
@@ -15634,7 +17969,7 @@
           </a:fontRef>
         </p:style>
         <p:txBody>
-          <a:bodyPr rtlCol="0" anchor="ctr" wrap="none" lIns="0" rIns="0" tIns="0" bIns="0"/>
+          <a:bodyPr wrap="none" lIns="0" tIns="0" rIns="0" bIns="0" rtlCol="0" anchor="ctr"/>
           <a:lstStyle/>
           <a:p>
             <a:pPr algn="ctr"/>
@@ -15691,7 +18026,7 @@
           </a:fontRef>
         </p:style>
         <p:txBody>
-          <a:bodyPr rtlCol="0" anchor="ctr" wrap="square" lIns="96012" rIns="82296" tIns="41148" bIns="41148"/>
+          <a:bodyPr wrap="square" lIns="96012" tIns="41148" rIns="82296" bIns="41148" rtlCol="0" anchor="ctr"/>
           <a:lstStyle/>
           <a:p>
             <a:pPr algn="l">
@@ -15767,7 +18102,7 @@
           </a:fontRef>
         </p:style>
         <p:txBody>
-          <a:bodyPr rtlCol="0" anchor="ctr" wrap="none" lIns="0" rIns="0" tIns="0" bIns="0"/>
+          <a:bodyPr wrap="none" lIns="0" tIns="0" rIns="0" bIns="0" rtlCol="0" anchor="ctr"/>
           <a:lstStyle/>
           <a:p>
             <a:pPr algn="ctr"/>
@@ -15824,7 +18159,7 @@
           </a:fontRef>
         </p:style>
         <p:txBody>
-          <a:bodyPr rtlCol="0" anchor="ctr" wrap="square" lIns="96012" rIns="82296" tIns="41148" bIns="41148"/>
+          <a:bodyPr wrap="square" lIns="96012" tIns="41148" rIns="82296" bIns="41148" rtlCol="0" anchor="ctr"/>
           <a:lstStyle/>
           <a:p>
             <a:pPr algn="l">
@@ -15900,7 +18235,7 @@
           </a:fontRef>
         </p:style>
         <p:txBody>
-          <a:bodyPr rtlCol="0" anchor="ctr" wrap="none" lIns="0" rIns="0" tIns="0" bIns="0"/>
+          <a:bodyPr wrap="none" lIns="0" tIns="0" rIns="0" bIns="0" rtlCol="0" anchor="ctr"/>
           <a:lstStyle/>
           <a:p>
             <a:pPr algn="ctr"/>
@@ -16214,7 +18549,7 @@
           </a:fontRef>
         </p:style>
         <p:txBody>
-          <a:bodyPr rtlCol="0" anchor="ctr" wrap="square" lIns="82296" rIns="82296" tIns="0" bIns="0"/>
+          <a:bodyPr wrap="square" lIns="82296" tIns="0" rIns="82296" bIns="0" rtlCol="0" anchor="ctr"/>
           <a:lstStyle/>
           <a:p>
             <a:pPr algn="ctr"/>
@@ -16273,7 +18608,7 @@
 </file>
 
 <file path=ppt/slides/slide6.xml><?xml version="1.0" encoding="utf-8"?>
-<p:sld xmlns:a="http://schemas.openxmlformats.org/drawingml/2006/main" xmlns:p="http://schemas.openxmlformats.org/presentationml/2006/main" xmlns:r="http://schemas.openxmlformats.org/officeDocument/2006/relationships">
+<p:sld xmlns:a="http://schemas.openxmlformats.org/drawingml/2006/main" xmlns:r="http://schemas.openxmlformats.org/officeDocument/2006/relationships" xmlns:p="http://schemas.openxmlformats.org/presentationml/2006/main">
   <p:cSld>
     <p:spTree>
       <p:nvGrpSpPr>
@@ -16281,7 +18616,14 @@
         <p:cNvGrpSpPr/>
         <p:nvPr/>
       </p:nvGrpSpPr>
-      <p:grpSpPr/>
+      <p:grpSpPr>
+        <a:xfrm>
+          <a:off x="0" y="0"/>
+          <a:ext cx="0" cy="0"/>
+          <a:chOff x="0" y="0"/>
+          <a:chExt cx="0" cy="0"/>
+        </a:xfrm>
+      </p:grpSpPr>
       <p:sp>
         <p:nvSpPr>
           <p:cNvPr id="2" name="Rectangle 1"/>
@@ -16323,6 +18665,7 @@
           <a:lstStyle/>
           <a:p>
             <a:pPr algn="ctr"/>
+            <a:endParaRPr/>
           </a:p>
         </p:txBody>
       </p:sp>
@@ -16343,7 +18686,7 @@
           <a:noFill/>
         </p:spPr>
         <p:txBody>
-          <a:bodyPr wrap="square" anchor="t" lIns="0" rIns="0" tIns="0" bIns="0">
+          <a:bodyPr wrap="square" lIns="0" tIns="0" rIns="0" bIns="0" anchor="t">
             <a:spAutoFit/>
           </a:bodyPr>
           <a:lstStyle/>
@@ -16428,7 +18771,7 @@
           </a:fontRef>
         </p:style>
         <p:txBody>
-          <a:bodyPr rtlCol="0" anchor="ctr" wrap="square" lIns="96012" rIns="82296" tIns="41148" bIns="41148"/>
+          <a:bodyPr wrap="square" lIns="96012" tIns="41148" rIns="82296" bIns="41148" rtlCol="0" anchor="ctr"/>
           <a:lstStyle/>
           <a:p>
             <a:pPr algn="l">
@@ -16504,7 +18847,7 @@
           </a:fontRef>
         </p:style>
         <p:txBody>
-          <a:bodyPr rtlCol="0" anchor="ctr" wrap="none" lIns="0" rIns="0" tIns="0" bIns="0"/>
+          <a:bodyPr wrap="none" lIns="0" tIns="0" rIns="0" bIns="0" rtlCol="0" anchor="ctr"/>
           <a:lstStyle/>
           <a:p>
             <a:pPr algn="ctr"/>
@@ -16561,7 +18904,7 @@
           </a:fontRef>
         </p:style>
         <p:txBody>
-          <a:bodyPr rtlCol="0" anchor="ctr" wrap="square" lIns="96012" rIns="82296" tIns="41148" bIns="41148"/>
+          <a:bodyPr wrap="square" lIns="96012" tIns="41148" rIns="82296" bIns="41148" rtlCol="0" anchor="ctr"/>
           <a:lstStyle/>
           <a:p>
             <a:pPr algn="l">
@@ -16637,7 +18980,7 @@
           </a:fontRef>
         </p:style>
         <p:txBody>
-          <a:bodyPr rtlCol="0" anchor="ctr" wrap="none" lIns="0" rIns="0" tIns="0" bIns="0"/>
+          <a:bodyPr wrap="none" lIns="0" tIns="0" rIns="0" bIns="0" rtlCol="0" anchor="ctr"/>
           <a:lstStyle/>
           <a:p>
             <a:pPr algn="ctr"/>
@@ -16694,7 +19037,7 @@
           </a:fontRef>
         </p:style>
         <p:txBody>
-          <a:bodyPr rtlCol="0" anchor="ctr" wrap="square" lIns="96012" rIns="82296" tIns="41148" bIns="41148"/>
+          <a:bodyPr wrap="square" lIns="96012" tIns="41148" rIns="82296" bIns="41148" rtlCol="0" anchor="ctr"/>
           <a:lstStyle/>
           <a:p>
             <a:pPr algn="l">
@@ -16770,7 +19113,7 @@
           </a:fontRef>
         </p:style>
         <p:txBody>
-          <a:bodyPr rtlCol="0" anchor="ctr" wrap="none" lIns="0" rIns="0" tIns="0" bIns="0"/>
+          <a:bodyPr wrap="none" lIns="0" tIns="0" rIns="0" bIns="0" rtlCol="0" anchor="ctr"/>
           <a:lstStyle/>
           <a:p>
             <a:pPr algn="ctr"/>
@@ -16827,7 +19170,7 @@
           </a:fontRef>
         </p:style>
         <p:txBody>
-          <a:bodyPr rtlCol="0" anchor="ctr" wrap="square" lIns="96012" rIns="82296" tIns="41148" bIns="41148"/>
+          <a:bodyPr wrap="square" lIns="96012" tIns="41148" rIns="82296" bIns="41148" rtlCol="0" anchor="ctr"/>
           <a:lstStyle/>
           <a:p>
             <a:pPr algn="l">
@@ -16903,7 +19246,7 @@
           </a:fontRef>
         </p:style>
         <p:txBody>
-          <a:bodyPr rtlCol="0" anchor="ctr" wrap="none" lIns="0" rIns="0" tIns="0" bIns="0"/>
+          <a:bodyPr wrap="none" lIns="0" tIns="0" rIns="0" bIns="0" rtlCol="0" anchor="ctr"/>
           <a:lstStyle/>
           <a:p>
             <a:pPr algn="ctr"/>
@@ -16960,7 +19303,7 @@
           </a:fontRef>
         </p:style>
         <p:txBody>
-          <a:bodyPr rtlCol="0" anchor="ctr" wrap="square" lIns="96012" rIns="82296" tIns="41148" bIns="41148"/>
+          <a:bodyPr wrap="square" lIns="96012" tIns="41148" rIns="82296" bIns="41148" rtlCol="0" anchor="ctr"/>
           <a:lstStyle/>
           <a:p>
             <a:pPr algn="l">
@@ -17036,7 +19379,7 @@
           </a:fontRef>
         </p:style>
         <p:txBody>
-          <a:bodyPr rtlCol="0" anchor="ctr" wrap="none" lIns="0" rIns="0" tIns="0" bIns="0"/>
+          <a:bodyPr wrap="none" lIns="0" tIns="0" rIns="0" bIns="0" rtlCol="0" anchor="ctr"/>
           <a:lstStyle/>
           <a:p>
             <a:pPr algn="ctr"/>
@@ -17093,7 +19436,7 @@
           </a:fontRef>
         </p:style>
         <p:txBody>
-          <a:bodyPr rtlCol="0" anchor="ctr" wrap="square" lIns="96012" rIns="82296" tIns="41148" bIns="41148"/>
+          <a:bodyPr wrap="square" lIns="96012" tIns="41148" rIns="82296" bIns="41148" rtlCol="0" anchor="ctr"/>
           <a:lstStyle/>
           <a:p>
             <a:pPr algn="l">
@@ -17169,7 +19512,7 @@
           </a:fontRef>
         </p:style>
         <p:txBody>
-          <a:bodyPr rtlCol="0" anchor="ctr" wrap="none" lIns="0" rIns="0" tIns="0" bIns="0"/>
+          <a:bodyPr wrap="none" lIns="0" tIns="0" rIns="0" bIns="0" rtlCol="0" anchor="ctr"/>
           <a:lstStyle/>
           <a:p>
             <a:pPr algn="ctr"/>
@@ -17226,7 +19569,7 @@
           </a:fontRef>
         </p:style>
         <p:txBody>
-          <a:bodyPr rtlCol="0" anchor="ctr" wrap="square" lIns="96012" rIns="82296" tIns="41148" bIns="41148"/>
+          <a:bodyPr wrap="square" lIns="96012" tIns="41148" rIns="82296" bIns="41148" rtlCol="0" anchor="ctr"/>
           <a:lstStyle/>
           <a:p>
             <a:pPr algn="l">
@@ -17302,7 +19645,7 @@
           </a:fontRef>
         </p:style>
         <p:txBody>
-          <a:bodyPr rtlCol="0" anchor="ctr" wrap="none" lIns="0" rIns="0" tIns="0" bIns="0"/>
+          <a:bodyPr wrap="none" lIns="0" tIns="0" rIns="0" bIns="0" rtlCol="0" anchor="ctr"/>
           <a:lstStyle/>
           <a:p>
             <a:pPr algn="ctr"/>
@@ -17359,7 +19702,7 @@
           </a:fontRef>
         </p:style>
         <p:txBody>
-          <a:bodyPr rtlCol="0" anchor="ctr" wrap="square" lIns="96012" rIns="82296" tIns="41148" bIns="41148"/>
+          <a:bodyPr wrap="square" lIns="96012" tIns="41148" rIns="82296" bIns="41148" rtlCol="0" anchor="ctr"/>
           <a:lstStyle/>
           <a:p>
             <a:pPr algn="l">
@@ -17435,7 +19778,7 @@
           </a:fontRef>
         </p:style>
         <p:txBody>
-          <a:bodyPr rtlCol="0" anchor="ctr" wrap="none" lIns="0" rIns="0" tIns="0" bIns="0"/>
+          <a:bodyPr wrap="none" lIns="0" tIns="0" rIns="0" bIns="0" rtlCol="0" anchor="ctr"/>
           <a:lstStyle/>
           <a:p>
             <a:pPr algn="ctr"/>
@@ -17749,7 +20092,7 @@
           </a:fontRef>
         </p:style>
         <p:txBody>
-          <a:bodyPr rtlCol="0" anchor="ctr" wrap="square" lIns="82296" rIns="82296" tIns="0" bIns="0"/>
+          <a:bodyPr wrap="square" lIns="82296" tIns="0" rIns="82296" bIns="0" rtlCol="0" anchor="ctr"/>
           <a:lstStyle/>
           <a:p>
             <a:pPr algn="ctr"/>
@@ -17808,7 +20151,7 @@
 </file>
 
 <file path=ppt/slides/slide7.xml><?xml version="1.0" encoding="utf-8"?>
-<p:sld xmlns:a="http://schemas.openxmlformats.org/drawingml/2006/main" xmlns:p="http://schemas.openxmlformats.org/presentationml/2006/main" xmlns:r="http://schemas.openxmlformats.org/officeDocument/2006/relationships">
+<p:sld xmlns:a="http://schemas.openxmlformats.org/drawingml/2006/main" xmlns:r="http://schemas.openxmlformats.org/officeDocument/2006/relationships" xmlns:p="http://schemas.openxmlformats.org/presentationml/2006/main">
   <p:cSld>
     <p:spTree>
       <p:nvGrpSpPr>
@@ -17816,7 +20159,14 @@
         <p:cNvGrpSpPr/>
         <p:nvPr/>
       </p:nvGrpSpPr>
-      <p:grpSpPr/>
+      <p:grpSpPr>
+        <a:xfrm>
+          <a:off x="0" y="0"/>
+          <a:ext cx="0" cy="0"/>
+          <a:chOff x="0" y="0"/>
+          <a:chExt cx="0" cy="0"/>
+        </a:xfrm>
+      </p:grpSpPr>
       <p:sp>
         <p:nvSpPr>
           <p:cNvPr id="2" name="Rectangle 1"/>
@@ -17858,6 +20208,7 @@
           <a:lstStyle/>
           <a:p>
             <a:pPr algn="ctr"/>
+            <a:endParaRPr/>
           </a:p>
         </p:txBody>
       </p:sp>
@@ -17878,7 +20229,7 @@
           <a:noFill/>
         </p:spPr>
         <p:txBody>
-          <a:bodyPr wrap="square" anchor="t" lIns="0" rIns="0" tIns="0" bIns="0">
+          <a:bodyPr wrap="square" lIns="0" tIns="0" rIns="0" bIns="0" anchor="t">
             <a:spAutoFit/>
           </a:bodyPr>
           <a:lstStyle/>
@@ -17963,7 +20314,7 @@
           </a:fontRef>
         </p:style>
         <p:txBody>
-          <a:bodyPr rtlCol="0" anchor="ctr" wrap="square" lIns="96012" rIns="82296" tIns="41148" bIns="41148"/>
+          <a:bodyPr wrap="square" lIns="96012" tIns="41148" rIns="82296" bIns="41148" rtlCol="0" anchor="ctr"/>
           <a:lstStyle/>
           <a:p>
             <a:pPr algn="l">
@@ -18039,7 +20390,7 @@
           </a:fontRef>
         </p:style>
         <p:txBody>
-          <a:bodyPr rtlCol="0" anchor="ctr" wrap="none" lIns="0" rIns="0" tIns="0" bIns="0"/>
+          <a:bodyPr wrap="none" lIns="0" tIns="0" rIns="0" bIns="0" rtlCol="0" anchor="ctr"/>
           <a:lstStyle/>
           <a:p>
             <a:pPr algn="ctr"/>
@@ -18096,7 +20447,7 @@
           </a:fontRef>
         </p:style>
         <p:txBody>
-          <a:bodyPr rtlCol="0" anchor="ctr" wrap="square" lIns="96012" rIns="82296" tIns="41148" bIns="41148"/>
+          <a:bodyPr wrap="square" lIns="96012" tIns="41148" rIns="82296" bIns="41148" rtlCol="0" anchor="ctr"/>
           <a:lstStyle/>
           <a:p>
             <a:pPr algn="l">
@@ -18172,7 +20523,7 @@
           </a:fontRef>
         </p:style>
         <p:txBody>
-          <a:bodyPr rtlCol="0" anchor="ctr" wrap="none" lIns="0" rIns="0" tIns="0" bIns="0"/>
+          <a:bodyPr wrap="none" lIns="0" tIns="0" rIns="0" bIns="0" rtlCol="0" anchor="ctr"/>
           <a:lstStyle/>
           <a:p>
             <a:pPr algn="ctr"/>
@@ -18229,7 +20580,7 @@
           </a:fontRef>
         </p:style>
         <p:txBody>
-          <a:bodyPr rtlCol="0" anchor="ctr" wrap="square" lIns="96012" rIns="82296" tIns="41148" bIns="41148"/>
+          <a:bodyPr wrap="square" lIns="96012" tIns="41148" rIns="82296" bIns="41148" rtlCol="0" anchor="ctr"/>
           <a:lstStyle/>
           <a:p>
             <a:pPr algn="l">
@@ -18305,7 +20656,7 @@
           </a:fontRef>
         </p:style>
         <p:txBody>
-          <a:bodyPr rtlCol="0" anchor="ctr" wrap="none" lIns="0" rIns="0" tIns="0" bIns="0"/>
+          <a:bodyPr wrap="none" lIns="0" tIns="0" rIns="0" bIns="0" rtlCol="0" anchor="ctr"/>
           <a:lstStyle/>
           <a:p>
             <a:pPr algn="ctr"/>
@@ -18362,7 +20713,7 @@
           </a:fontRef>
         </p:style>
         <p:txBody>
-          <a:bodyPr rtlCol="0" anchor="ctr" wrap="square" lIns="96012" rIns="82296" tIns="41148" bIns="41148"/>
+          <a:bodyPr wrap="square" lIns="96012" tIns="41148" rIns="82296" bIns="41148" rtlCol="0" anchor="ctr"/>
           <a:lstStyle/>
           <a:p>
             <a:pPr algn="l">
@@ -18438,7 +20789,7 @@
           </a:fontRef>
         </p:style>
         <p:txBody>
-          <a:bodyPr rtlCol="0" anchor="ctr" wrap="none" lIns="0" rIns="0" tIns="0" bIns="0"/>
+          <a:bodyPr wrap="none" lIns="0" tIns="0" rIns="0" bIns="0" rtlCol="0" anchor="ctr"/>
           <a:lstStyle/>
           <a:p>
             <a:pPr algn="ctr"/>
@@ -18495,7 +20846,7 @@
           </a:fontRef>
         </p:style>
         <p:txBody>
-          <a:bodyPr rtlCol="0" anchor="ctr" wrap="square" lIns="96012" rIns="82296" tIns="41148" bIns="41148"/>
+          <a:bodyPr wrap="square" lIns="96012" tIns="41148" rIns="82296" bIns="41148" rtlCol="0" anchor="ctr"/>
           <a:lstStyle/>
           <a:p>
             <a:pPr algn="l">
@@ -18571,7 +20922,7 @@
           </a:fontRef>
         </p:style>
         <p:txBody>
-          <a:bodyPr rtlCol="0" anchor="ctr" wrap="none" lIns="0" rIns="0" tIns="0" bIns="0"/>
+          <a:bodyPr wrap="none" lIns="0" tIns="0" rIns="0" bIns="0" rtlCol="0" anchor="ctr"/>
           <a:lstStyle/>
           <a:p>
             <a:pPr algn="ctr"/>
@@ -18628,7 +20979,7 @@
           </a:fontRef>
         </p:style>
         <p:txBody>
-          <a:bodyPr rtlCol="0" anchor="ctr" wrap="square" lIns="96012" rIns="82296" tIns="41148" bIns="41148"/>
+          <a:bodyPr wrap="square" lIns="96012" tIns="41148" rIns="82296" bIns="41148" rtlCol="0" anchor="ctr"/>
           <a:lstStyle/>
           <a:p>
             <a:pPr algn="l">
@@ -18704,7 +21055,7 @@
           </a:fontRef>
         </p:style>
         <p:txBody>
-          <a:bodyPr rtlCol="0" anchor="ctr" wrap="none" lIns="0" rIns="0" tIns="0" bIns="0"/>
+          <a:bodyPr wrap="none" lIns="0" tIns="0" rIns="0" bIns="0" rtlCol="0" anchor="ctr"/>
           <a:lstStyle/>
           <a:p>
             <a:pPr algn="ctr"/>
@@ -18944,7 +21295,7 @@
           </a:fontRef>
         </p:style>
         <p:txBody>
-          <a:bodyPr rtlCol="0" anchor="ctr" wrap="square" lIns="82296" rIns="82296" tIns="0" bIns="0"/>
+          <a:bodyPr wrap="square" lIns="82296" tIns="0" rIns="82296" bIns="0" rtlCol="0" anchor="ctr"/>
           <a:lstStyle/>
           <a:p>
             <a:pPr algn="ctr"/>
@@ -19003,7 +21354,7 @@
 </file>
 
 <file path=ppt/slides/slide8.xml><?xml version="1.0" encoding="utf-8"?>
-<p:sld xmlns:a="http://schemas.openxmlformats.org/drawingml/2006/main" xmlns:p="http://schemas.openxmlformats.org/presentationml/2006/main" xmlns:r="http://schemas.openxmlformats.org/officeDocument/2006/relationships">
+<p:sld xmlns:a="http://schemas.openxmlformats.org/drawingml/2006/main" xmlns:r="http://schemas.openxmlformats.org/officeDocument/2006/relationships" xmlns:p="http://schemas.openxmlformats.org/presentationml/2006/main">
   <p:cSld>
     <p:spTree>
       <p:nvGrpSpPr>
@@ -19011,7 +21362,14 @@
         <p:cNvGrpSpPr/>
         <p:nvPr/>
       </p:nvGrpSpPr>
-      <p:grpSpPr/>
+      <p:grpSpPr>
+        <a:xfrm>
+          <a:off x="0" y="0"/>
+          <a:ext cx="0" cy="0"/>
+          <a:chOff x="0" y="0"/>
+          <a:chExt cx="0" cy="0"/>
+        </a:xfrm>
+      </p:grpSpPr>
       <p:sp>
         <p:nvSpPr>
           <p:cNvPr id="2" name="Rectangle 1"/>
@@ -19053,6 +21411,7 @@
           <a:lstStyle/>
           <a:p>
             <a:pPr algn="ctr"/>
+            <a:endParaRPr/>
           </a:p>
         </p:txBody>
       </p:sp>
@@ -19073,7 +21432,7 @@
           <a:noFill/>
         </p:spPr>
         <p:txBody>
-          <a:bodyPr wrap="square" anchor="t" lIns="0" rIns="0" tIns="0" bIns="0">
+          <a:bodyPr wrap="square" lIns="0" tIns="0" rIns="0" bIns="0" anchor="t">
             <a:spAutoFit/>
           </a:bodyPr>
           <a:lstStyle/>
@@ -19175,7 +21534,7 @@
           </a:fontRef>
         </p:style>
         <p:txBody>
-          <a:bodyPr rtlCol="0" anchor="ctr" lIns="96012" tIns="0" bIns="0"/>
+          <a:bodyPr lIns="96012" tIns="0" bIns="0" rtlCol="0" anchor="ctr"/>
           <a:lstStyle/>
           <a:p>
             <a:pPr algn="ctr"/>
@@ -19232,7 +21591,7 @@
           </a:fontRef>
         </p:style>
         <p:txBody>
-          <a:bodyPr rtlCol="0" anchor="t" wrap="square" lIns="123444" rIns="96012" tIns="82296"/>
+          <a:bodyPr wrap="square" lIns="123444" tIns="82296" rIns="96012" rtlCol="0" anchor="t"/>
           <a:lstStyle/>
           <a:p>
             <a:pPr algn="l">
@@ -19427,7 +21786,7 @@
           </a:fontRef>
         </p:style>
         <p:txBody>
-          <a:bodyPr rtlCol="0" anchor="ctr" lIns="96012" tIns="0" bIns="0"/>
+          <a:bodyPr lIns="96012" tIns="0" bIns="0" rtlCol="0" anchor="ctr"/>
           <a:lstStyle/>
           <a:p>
             <a:pPr algn="ctr"/>
@@ -19484,7 +21843,7 @@
           </a:fontRef>
         </p:style>
         <p:txBody>
-          <a:bodyPr rtlCol="0" anchor="t" wrap="square" lIns="123444" rIns="96012" tIns="82296"/>
+          <a:bodyPr wrap="square" lIns="123444" tIns="82296" rIns="96012" rtlCol="0" anchor="t"/>
           <a:lstStyle/>
           <a:p>
             <a:pPr algn="l">
@@ -19679,7 +22038,7 @@
           </a:fontRef>
         </p:style>
         <p:txBody>
-          <a:bodyPr rtlCol="0" anchor="ctr" lIns="96012" tIns="0" bIns="0"/>
+          <a:bodyPr lIns="96012" tIns="0" bIns="0" rtlCol="0" anchor="ctr"/>
           <a:lstStyle/>
           <a:p>
             <a:pPr algn="ctr"/>
@@ -19736,7 +22095,7 @@
           </a:fontRef>
         </p:style>
         <p:txBody>
-          <a:bodyPr rtlCol="0" anchor="t" wrap="square" lIns="123444" rIns="96012" tIns="82296"/>
+          <a:bodyPr wrap="square" lIns="123444" tIns="82296" rIns="96012" rtlCol="0" anchor="t"/>
           <a:lstStyle/>
           <a:p>
             <a:pPr algn="l">
@@ -19967,7 +22326,7 @@
           </a:fontRef>
         </p:style>
         <p:txBody>
-          <a:bodyPr rtlCol="0" anchor="ctr" wrap="square" lIns="82296" rIns="82296" tIns="0" bIns="0"/>
+          <a:bodyPr wrap="square" lIns="82296" tIns="0" rIns="82296" bIns="0" rtlCol="0" anchor="ctr"/>
           <a:lstStyle/>
           <a:p>
             <a:pPr algn="ctr"/>
@@ -20026,7 +22385,7 @@
 </file>
 
 <file path=ppt/slides/slide9.xml><?xml version="1.0" encoding="utf-8"?>
-<p:sld xmlns:a="http://schemas.openxmlformats.org/drawingml/2006/main" xmlns:p="http://schemas.openxmlformats.org/presentationml/2006/main" xmlns:r="http://schemas.openxmlformats.org/officeDocument/2006/relationships">
+<p:sld xmlns:a="http://schemas.openxmlformats.org/drawingml/2006/main" xmlns:r="http://schemas.openxmlformats.org/officeDocument/2006/relationships" xmlns:p="http://schemas.openxmlformats.org/presentationml/2006/main">
   <p:cSld>
     <p:spTree>
       <p:nvGrpSpPr>
@@ -20034,7 +22393,14 @@
         <p:cNvGrpSpPr/>
         <p:nvPr/>
       </p:nvGrpSpPr>
-      <p:grpSpPr/>
+      <p:grpSpPr>
+        <a:xfrm>
+          <a:off x="0" y="0"/>
+          <a:ext cx="0" cy="0"/>
+          <a:chOff x="0" y="0"/>
+          <a:chExt cx="0" cy="0"/>
+        </a:xfrm>
+      </p:grpSpPr>
       <p:sp>
         <p:nvSpPr>
           <p:cNvPr id="2" name="Rectangle 1"/>
@@ -20076,6 +22442,7 @@
           <a:lstStyle/>
           <a:p>
             <a:pPr algn="ctr"/>
+            <a:endParaRPr/>
           </a:p>
         </p:txBody>
       </p:sp>
@@ -20096,7 +22463,7 @@
           <a:noFill/>
         </p:spPr>
         <p:txBody>
-          <a:bodyPr wrap="square" anchor="t" lIns="0" rIns="0" tIns="0" bIns="0">
+          <a:bodyPr wrap="square" lIns="0" tIns="0" rIns="0" bIns="0" anchor="t">
             <a:spAutoFit/>
           </a:bodyPr>
           <a:lstStyle/>
@@ -20200,7 +22567,7 @@
           </a:fontRef>
         </p:style>
         <p:txBody>
-          <a:bodyPr rtlCol="0" anchor="t" wrap="square" lIns="96012" rIns="82296" tIns="96012" bIns="41148"/>
+          <a:bodyPr wrap="square" lIns="96012" tIns="96012" rIns="82296" bIns="41148" rtlCol="0" anchor="t"/>
           <a:lstStyle/>
           <a:p>
             <a:pPr algn="l">
@@ -20280,6 +22647,7 @@
           <a:lstStyle/>
           <a:p>
             <a:pPr algn="ctr"/>
+            <a:endParaRPr/>
           </a:p>
         </p:txBody>
       </p:sp>
@@ -20324,7 +22692,7 @@
           </a:fontRef>
         </p:style>
         <p:txBody>
-          <a:bodyPr rtlCol="0" anchor="t" wrap="square" lIns="96012" rIns="82296" tIns="96012" bIns="41148"/>
+          <a:bodyPr wrap="square" lIns="96012" tIns="96012" rIns="82296" bIns="41148" rtlCol="0" anchor="t"/>
           <a:lstStyle/>
           <a:p>
             <a:pPr algn="l">
@@ -20404,6 +22772,7 @@
           <a:lstStyle/>
           <a:p>
             <a:pPr algn="ctr"/>
+            <a:endParaRPr/>
           </a:p>
         </p:txBody>
       </p:sp>
@@ -20448,7 +22817,7 @@
           </a:fontRef>
         </p:style>
         <p:txBody>
-          <a:bodyPr rtlCol="0" anchor="t" wrap="square" lIns="96012" rIns="82296" tIns="96012" bIns="41148"/>
+          <a:bodyPr wrap="square" lIns="96012" tIns="96012" rIns="82296" bIns="41148" rtlCol="0" anchor="t"/>
           <a:lstStyle/>
           <a:p>
             <a:pPr algn="l">
@@ -20528,6 +22897,7 @@
           <a:lstStyle/>
           <a:p>
             <a:pPr algn="ctr"/>
+            <a:endParaRPr/>
           </a:p>
         </p:txBody>
       </p:sp>
@@ -20572,7 +22942,7 @@
           </a:fontRef>
         </p:style>
         <p:txBody>
-          <a:bodyPr rtlCol="0" anchor="t" wrap="square" lIns="96012" rIns="82296" tIns="96012" bIns="41148"/>
+          <a:bodyPr wrap="square" lIns="96012" tIns="96012" rIns="82296" bIns="41148" rtlCol="0" anchor="t"/>
           <a:lstStyle/>
           <a:p>
             <a:pPr algn="l">
@@ -20652,6 +23022,7 @@
           <a:lstStyle/>
           <a:p>
             <a:pPr algn="ctr"/>
+            <a:endParaRPr/>
           </a:p>
         </p:txBody>
       </p:sp>
@@ -20684,7 +23055,7 @@
                 </a:solidFill>
                 <a:latin typeface="Arial"/>
               </a:rPr>
-              <a:t>Shop Well — client pitch  ·  9</a:t>
+              <a:t>Shop Well — client pitch  ·  10</a:t>
             </a:r>
           </a:p>
         </p:txBody>

</xml_diff>